<commit_message>
docs: update presentation to product-pitch framing
Regenerate BrokerCore-Presentacion.pptx to match the reworked HTML
deck: drop the changelog-style comisiones slide and the deployment
location slide, add a practical "qué registra" slide, replace the
route-count stat with a more relevant integrations count.
</commit_message>
<xml_diff>
--- a/docs/BrokerCore-Presentacion.pptx
+++ b/docs/BrokerCore-Presentacion.pptx
@@ -14,10 +14,9 @@
     <p:sldId id="262" r:id="rId8"/>
     <p:sldId id="263" r:id="rId9"/>
     <p:sldId id="264" r:id="rId10"/>
-    <p:sldId id="265" r:id="rId11"/>
   </p:sldIdLst>
   <p:notesMasterIdLst>
-    <p:notesMasterId r:id="rId12"/>
+    <p:notesMasterId r:id="rId11"/>
   </p:notesMasterIdLst>
   <p:sldSz cx="9144000" cy="5148072"/>
   <p:notesSz cx="5148072" cy="9144000"/>
@@ -535,94 +534,6 @@
             <a:fld id="{F7021451-1387-4CA6-816F-3879F97B5CBC}" type="slidenum">
               <a:rPr lang="en-US"/>
               <a:t>1</a:t>
-            </a:fld>
-            <a:endParaRPr lang="en-US"/>
-          </a:p>
-        </p:txBody>
-      </p:sp>
-    </p:spTree>
-    <p:extLst>
-      <p:ext uri="{BB962C8B-B14F-4D97-AF65-F5344CB8AC3E}">
-        <p14:creationId xmlns:p14="http://schemas.microsoft.com/office/powerpoint/2010/main" val="1024086991"/>
-      </p:ext>
-    </p:extLst>
-  </p:cSld>
-  <p:clrMapOvr>
-    <a:masterClrMapping/>
-  </p:clrMapOvr>
-</p:notes>
-</file>
-
-<file path=ppt/notesSlides/notesSlide10.xml><?xml version="1.0" encoding="utf-8"?>
-<p:notes xmlns:a="http://schemas.openxmlformats.org/drawingml/2006/main" xmlns:r="http://schemas.openxmlformats.org/officeDocument/2006/relationships" xmlns:p="http://schemas.openxmlformats.org/presentationml/2006/main">
-  <p:cSld>
-    <p:spTree>
-      <p:nvGrpSpPr>
-        <p:cNvPr id="1" name=""/>
-        <p:cNvGrpSpPr/>
-        <p:nvPr/>
-      </p:nvGrpSpPr>
-      <p:grpSpPr>
-        <a:xfrm>
-          <a:off x="0" y="0"/>
-          <a:ext cx="0" cy="0"/>
-          <a:chOff x="0" y="0"/>
-          <a:chExt cx="0" cy="0"/>
-        </a:xfrm>
-      </p:grpSpPr>
-      <p:sp>
-        <p:nvSpPr>
-          <p:cNvPr id="2" name="Slide Image Placeholder 1"/>
-          <p:cNvSpPr>
-            <a:spLocks noGrp="1" noRot="1" noChangeAspect="1"/>
-          </p:cNvSpPr>
-          <p:nvPr>
-            <p:ph type="sldImg"/>
-          </p:nvPr>
-        </p:nvSpPr>
-        <p:spPr/>
-      </p:sp>
-      <p:sp>
-        <p:nvSpPr>
-          <p:cNvPr id="3" name="Notes Placeholder 2"/>
-          <p:cNvSpPr>
-            <a:spLocks noGrp="1"/>
-          </p:cNvSpPr>
-          <p:nvPr>
-            <p:ph type="body" idx="1"/>
-          </p:nvPr>
-        </p:nvSpPr>
-        <p:spPr/>
-        <p:txBody>
-          <a:bodyPr/>
-          <a:lstStyle/>
-          <a:p>
-            <a:r>
-              <a:rPr lang="en-US" dirty="0"/>
-              <a:t/>
-            </a:r>
-            <a:endParaRPr lang="en-US" dirty="0"/>
-          </a:p>
-        </p:txBody>
-      </p:sp>
-      <p:sp>
-        <p:nvSpPr>
-          <p:cNvPr id="4" name="Slide Number Placeholder 3"/>
-          <p:cNvSpPr>
-            <a:spLocks noGrp="1"/>
-          </p:cNvSpPr>
-          <p:nvPr>
-            <p:ph type="sldNum" sz="quarter" idx="10"/>
-          </p:nvPr>
-        </p:nvSpPr>
-        <p:spPr/>
-        <p:txBody>
-          <a:bodyPr/>
-          <a:lstStyle/>
-          <a:p>
-            <a:fld id="{F7021451-1387-4CA6-816F-3879F97B5CBC}" type="slidenum">
-              <a:rPr lang="en-US"/>
-              <a:t>10</a:t>
             </a:fld>
             <a:endParaRPr lang="en-US"/>
           </a:p>
@@ -1756,7 +1667,7 @@
                 <a:ea typeface="Consolas" pitchFamily="34" charset="-122"/>
                 <a:cs typeface="Consolas" pitchFamily="34" charset="-120"/>
               </a:rPr>
-              <a:t>01</a:t>
+              <a:t>00</a:t>
             </a:r>
             <a:endParaRPr lang="en-US" sz="1100" dirty="0"/>
           </a:p>
@@ -1869,7 +1780,7 @@
         <p:spPr>
           <a:xfrm>
             <a:off x="640080" y="3246120"/>
-            <a:ext cx="7498080" cy="548640"/>
+            <a:ext cx="7498080" cy="822960"/>
           </a:xfrm>
           <a:prstGeom prst="rect">
             <a:avLst/>
@@ -1878,14 +1789,14 @@
           <a:ln/>
         </p:spPr>
         <p:txBody>
-          <a:bodyPr wrap="square" rtlCol="0" anchor="ctr"/>
+          <a:bodyPr wrap="square" rtlCol="0" anchor="t"/>
           <a:lstStyle/>
           <a:p>
             <a:pPr indent="0" marL="0">
               <a:buNone/>
             </a:pPr>
             <a:r>
-              <a:rPr lang="en-US" sz="2000" dirty="0">
+              <a:rPr lang="en-US" sz="1800" dirty="0">
                 <a:solidFill>
                   <a:srgbClr val="47563F"/>
                 </a:solidFill>
@@ -1893,9 +1804,9 @@
                 <a:ea typeface="Calibri" pitchFamily="34" charset="-122"/>
                 <a:cs typeface="Calibri" pitchFamily="34" charset="-120"/>
               </a:rPr>
-              <a:t>Sistema de gestión integral para corredoras de seguros</a:t>
+              <a:t>Sistema de gestión integral para corredoras de seguros: asegurados, pólizas, siniestros, comisiones y cobranza, en un solo lugar.</a:t>
             </a:r>
-            <a:endParaRPr lang="en-US" sz="2000" dirty="0"/>
+            <a:endParaRPr lang="en-US" sz="1800" dirty="0"/>
           </a:p>
         </p:txBody>
       </p:sp>
@@ -1932,301 +1843,7 @@
                 <a:ea typeface="Consolas" pitchFamily="34" charset="-122"/>
                 <a:cs typeface="Consolas" pitchFamily="34" charset="-120"/>
               </a:rPr>
-              <a:t>Presentación de proyecto · Julio 2026</a:t>
-            </a:r>
-            <a:endParaRPr lang="en-US" sz="900" dirty="0"/>
-          </a:p>
-        </p:txBody>
-      </p:sp>
-    </p:spTree>
-  </p:cSld>
-  <p:clrMapOvr>
-    <a:masterClrMapping/>
-  </p:clrMapOvr>
-</p:sld>
-</file>
-
-<file path=ppt/slides/slide10.xml><?xml version="1.0" encoding="utf-8"?>
-<p:sld xmlns:a="http://schemas.openxmlformats.org/drawingml/2006/main" xmlns:r="http://schemas.openxmlformats.org/officeDocument/2006/relationships" xmlns:p="http://schemas.openxmlformats.org/presentationml/2006/main">
-  <p:cSld name="Slide 10">
-    <p:bg>
-      <p:bgPr>
-        <a:solidFill>
-          <a:srgbClr val="E7EEE3"/>
-        </a:solidFill>
-      </p:bgPr>
-    </p:bg>
-    <p:spTree>
-      <p:nvGrpSpPr>
-        <p:cNvPr id="1" name=""/>
-        <p:cNvGrpSpPr/>
-        <p:nvPr/>
-      </p:nvGrpSpPr>
-      <p:grpSpPr>
-        <a:xfrm>
-          <a:off x="0" y="0"/>
-          <a:ext cx="0" cy="0"/>
-          <a:chOff x="0" y="0"/>
-          <a:chExt cx="0" cy="0"/>
-        </a:xfrm>
-      </p:grpSpPr>
-      <p:sp>
-        <p:nvSpPr>
-          <p:cNvPr id="2" name="Shape 0"/>
-          <p:cNvSpPr/>
-          <p:nvPr/>
-        </p:nvSpPr>
-        <p:spPr>
-          <a:xfrm>
-            <a:off x="109728" y="109728"/>
-            <a:ext cx="8924544" cy="4928616"/>
-          </a:xfrm>
-          <a:prstGeom prst="rect">
-            <a:avLst/>
-          </a:prstGeom>
-          <a:ln w="12700">
-            <a:solidFill>
-              <a:srgbClr val="A8BBA1"/>
-            </a:solidFill>
-            <a:prstDash val="solid"/>
-          </a:ln>
-        </p:spPr>
-      </p:sp>
-      <p:sp>
-        <p:nvSpPr>
-          <p:cNvPr id="3" name="Shape 1"/>
-          <p:cNvSpPr/>
-          <p:nvPr/>
-        </p:nvSpPr>
-        <p:spPr>
-          <a:xfrm>
-            <a:off x="109728" y="109728"/>
-            <a:ext cx="512064" cy="310896"/>
-          </a:xfrm>
-          <a:prstGeom prst="rect">
-            <a:avLst/>
-          </a:prstGeom>
-          <a:solidFill>
-            <a:srgbClr val="DCE6D5"/>
-          </a:solidFill>
-          <a:ln w="12700">
-            <a:solidFill>
-              <a:srgbClr val="A8BBA1"/>
-            </a:solidFill>
-            <a:prstDash val="solid"/>
-          </a:ln>
-        </p:spPr>
-      </p:sp>
-      <p:sp>
-        <p:nvSpPr>
-          <p:cNvPr id="4" name="Text 2"/>
-          <p:cNvSpPr/>
-          <p:nvPr/>
-        </p:nvSpPr>
-        <p:spPr>
-          <a:xfrm>
-            <a:off x="109728" y="109728"/>
-            <a:ext cx="512064" cy="310896"/>
-          </a:xfrm>
-          <a:prstGeom prst="rect">
-            <a:avLst/>
-          </a:prstGeom>
-          <a:noFill/>
-          <a:ln/>
-        </p:spPr>
-        <p:txBody>
-          <a:bodyPr wrap="square" rtlCol="0" anchor="ctr"/>
-          <a:lstStyle/>
-          <a:p>
-            <a:pPr algn="ctr" indent="0" marL="0">
-              <a:buNone/>
-            </a:pPr>
-            <a:r>
-              <a:rPr lang="en-US" sz="1100" b="1" dirty="0">
-                <a:solidFill>
-                  <a:srgbClr val="93713D"/>
-                </a:solidFill>
-                <a:latin typeface="Consolas" pitchFamily="34" charset="0"/>
-                <a:ea typeface="Consolas" pitchFamily="34" charset="-122"/>
-                <a:cs typeface="Consolas" pitchFamily="34" charset="-120"/>
-              </a:rPr>
-              <a:t>10</a:t>
-            </a:r>
-            <a:endParaRPr lang="en-US" sz="1100" dirty="0"/>
-          </a:p>
-        </p:txBody>
-      </p:sp>
-      <p:sp>
-        <p:nvSpPr>
-          <p:cNvPr id="5" name="Text 3"/>
-          <p:cNvSpPr/>
-          <p:nvPr/>
-        </p:nvSpPr>
-        <p:spPr>
-          <a:xfrm>
-            <a:off x="640080" y="502920"/>
-            <a:ext cx="7863840" cy="274320"/>
-          </a:xfrm>
-          <a:prstGeom prst="rect">
-            <a:avLst/>
-          </a:prstGeom>
-          <a:noFill/>
-          <a:ln/>
-        </p:spPr>
-        <p:txBody>
-          <a:bodyPr wrap="square" rtlCol="0" anchor="ctr"/>
-          <a:lstStyle/>
-          <a:p>
-            <a:pPr indent="0" marL="0">
-              <a:buNone/>
-            </a:pPr>
-            <a:r>
-              <a:rPr lang="en-US" sz="1100" b="1" spc="200" kern="0" dirty="0">
-                <a:solidFill>
-                  <a:srgbClr val="93713D"/>
-                </a:solidFill>
-                <a:latin typeface="Consolas" pitchFamily="34" charset="0"/>
-                <a:ea typeface="Consolas" pitchFamily="34" charset="-122"/>
-                <a:cs typeface="Consolas" pitchFamily="34" charset="-120"/>
-              </a:rPr>
-              <a:t>CIERRE</a:t>
-            </a:r>
-            <a:endParaRPr lang="en-US" sz="1100" dirty="0"/>
-          </a:p>
-        </p:txBody>
-      </p:sp>
-      <p:sp>
-        <p:nvSpPr>
-          <p:cNvPr id="6" name="Text 4"/>
-          <p:cNvSpPr/>
-          <p:nvPr/>
-        </p:nvSpPr>
-        <p:spPr>
-          <a:xfrm>
-            <a:off x="640080" y="1737360"/>
-            <a:ext cx="7863840" cy="1005840"/>
-          </a:xfrm>
-          <a:prstGeom prst="rect">
-            <a:avLst/>
-          </a:prstGeom>
-          <a:noFill/>
-          <a:ln/>
-        </p:spPr>
-        <p:txBody>
-          <a:bodyPr wrap="square" rtlCol="0" anchor="ctr"/>
-          <a:lstStyle/>
-          <a:p>
-            <a:pPr indent="0" marL="0">
-              <a:buNone/>
-            </a:pPr>
-            <a:r>
-              <a:rPr lang="en-US" sz="4400" b="1" dirty="0">
-                <a:solidFill>
-                  <a:srgbClr val="16241B"/>
-                </a:solidFill>
-                <a:latin typeface="Georgia" pitchFamily="34" charset="0"/>
-                <a:ea typeface="Georgia" pitchFamily="34" charset="-122"/>
-                <a:cs typeface="Georgia" pitchFamily="34" charset="-120"/>
-              </a:rPr>
-              <a:t>Ahora, en vivo.</a:t>
-            </a:r>
-            <a:endParaRPr lang="en-US" sz="4400" dirty="0"/>
-          </a:p>
-        </p:txBody>
-      </p:sp>
-      <p:sp>
-        <p:nvSpPr>
-          <p:cNvPr id="7" name="Shape 5"/>
-          <p:cNvSpPr/>
-          <p:nvPr/>
-        </p:nvSpPr>
-        <p:spPr>
-          <a:xfrm>
-            <a:off x="658368" y="2743200"/>
-            <a:ext cx="2194560" cy="54864"/>
-          </a:xfrm>
-          <a:prstGeom prst="rect">
-            <a:avLst/>
-          </a:prstGeom>
-          <a:solidFill>
-            <a:srgbClr val="1A56DB"/>
-          </a:solidFill>
-          <a:ln/>
-        </p:spPr>
-      </p:sp>
-      <p:sp>
-        <p:nvSpPr>
-          <p:cNvPr id="8" name="Text 6"/>
-          <p:cNvSpPr/>
-          <p:nvPr/>
-        </p:nvSpPr>
-        <p:spPr>
-          <a:xfrm>
-            <a:off x="640080" y="2926080"/>
-            <a:ext cx="7680960" cy="548640"/>
-          </a:xfrm>
-          <a:prstGeom prst="rect">
-            <a:avLst/>
-          </a:prstGeom>
-          <a:noFill/>
-          <a:ln/>
-        </p:spPr>
-        <p:txBody>
-          <a:bodyPr wrap="square" rtlCol="0" anchor="ctr"/>
-          <a:lstStyle/>
-          <a:p>
-            <a:pPr indent="0" marL="0">
-              <a:buNone/>
-            </a:pPr>
-            <a:r>
-              <a:rPr lang="en-US" sz="1600" b="1" dirty="0">
-                <a:solidFill>
-                  <a:srgbClr val="93713D"/>
-                </a:solidFill>
-                <a:latin typeface="Consolas" pitchFamily="34" charset="0"/>
-                <a:ea typeface="Consolas" pitchFamily="34" charset="-122"/>
-                <a:cs typeface="Consolas" pitchFamily="34" charset="-120"/>
-              </a:rPr>
-              <a:t>Demo: asegurado → póliza → pago → comisión → reportes.</a:t>
-            </a:r>
-            <a:endParaRPr lang="en-US" sz="1600" dirty="0"/>
-          </a:p>
-        </p:txBody>
-      </p:sp>
-      <p:sp>
-        <p:nvSpPr>
-          <p:cNvPr id="9" name="Text 7"/>
-          <p:cNvSpPr/>
-          <p:nvPr/>
-        </p:nvSpPr>
-        <p:spPr>
-          <a:xfrm>
-            <a:off x="640080" y="4690872"/>
-            <a:ext cx="7863840" cy="274320"/>
-          </a:xfrm>
-          <a:prstGeom prst="rect">
-            <a:avLst/>
-          </a:prstGeom>
-          <a:noFill/>
-          <a:ln/>
-        </p:spPr>
-        <p:txBody>
-          <a:bodyPr wrap="square" rtlCol="0" anchor="ctr"/>
-          <a:lstStyle/>
-          <a:p>
-            <a:pPr indent="0" marL="0">
-              <a:buNone/>
-            </a:pPr>
-            <a:r>
-              <a:rPr lang="en-US" sz="900" dirty="0">
-                <a:solidFill>
-                  <a:srgbClr val="47563F"/>
-                </a:solidFill>
-                <a:latin typeface="Consolas" pitchFamily="34" charset="0"/>
-                <a:ea typeface="Consolas" pitchFamily="34" charset="-122"/>
-                <a:cs typeface="Consolas" pitchFamily="34" charset="-120"/>
-              </a:rPr>
-              <a:t>BrokerCore · Presentación de proyecto · Julio 2026</a:t>
+              <a:t>Una plataforma. Toda la operación.</a:t>
             </a:r>
             <a:endParaRPr lang="en-US" sz="900" dirty="0"/>
           </a:p>
@@ -2344,7 +1961,7 @@
                 <a:ea typeface="Consolas" pitchFamily="34" charset="-122"/>
                 <a:cs typeface="Consolas" pitchFamily="34" charset="-120"/>
               </a:rPr>
-              <a:t>02</a:t>
+              <a:t>01</a:t>
             </a:r>
             <a:endParaRPr lang="en-US" sz="1100" dirty="0"/>
           </a:p>
@@ -2520,7 +2137,7 @@
                 <a:ea typeface="Calibri" pitchFamily="34" charset="-122"/>
                 <a:cs typeface="Calibri" pitchFamily="34" charset="-120"/>
               </a:rPr>
-              <a:t>Errores por captura manual, al transcribir el mismo dato entre planillas</a:t>
+              <a:t>Errores por captura manual y duplicada de la misma información</a:t>
             </a:r>
             <a:endParaRPr lang="en-US" sz="1400" dirty="0"/>
           </a:p>
@@ -2579,7 +2196,7 @@
                 <a:ea typeface="Calibri" pitchFamily="34" charset="-122"/>
                 <a:cs typeface="Calibri" pitchFamily="34" charset="-120"/>
               </a:rPr>
-              <a:t>Trabajo repetido: la misma información se carga varias veces</a:t>
+              <a:t>Trabajo repetido entre planillas que no se hablan entre sí</a:t>
             </a:r>
             <a:endParaRPr lang="en-US" sz="1400" dirty="0"/>
           </a:p>
@@ -2756,7 +2373,7 @@
                 <a:ea typeface="Consolas" pitchFamily="34" charset="-122"/>
                 <a:cs typeface="Consolas" pitchFamily="34" charset="-120"/>
               </a:rPr>
-              <a:t>03</a:t>
+              <a:t>02</a:t>
             </a:r>
             <a:endParaRPr lang="en-US" sz="1100" dirty="0"/>
           </a:p>
@@ -2873,7 +2490,7 @@
                 <a:ea typeface="Calibri" pitchFamily="34" charset="-122"/>
                 <a:cs typeface="Calibri" pitchFamily="34" charset="-120"/>
               </a:rPr>
-              <a:t>Un sistema de gestión integral, web, para corredoras de seguros, que centraliza toda la operación en una única plataforma accesible desde cualquier navegador.</a:t>
+              <a:t>BrokerCore centraliza toda la operación diaria de la corredora en una única plataforma, accesible desde cualquier navegador, sin depender de planillas dispersas.</a:t>
             </a:r>
             <a:endParaRPr lang="en-US" sz="1500" dirty="0"/>
           </a:p>
@@ -3143,7 +2760,7 @@
                 <a:ea typeface="Georgia" pitchFamily="34" charset="-122"/>
                 <a:cs typeface="Georgia" pitchFamily="34" charset="-120"/>
               </a:rPr>
-              <a:t>173</a:t>
+              <a:t>9</a:t>
             </a:r>
             <a:endParaRPr lang="en-US" sz="3600" dirty="0"/>
           </a:p>
@@ -3182,7 +2799,7 @@
                 <a:ea typeface="Consolas" pitchFamily="34" charset="-122"/>
                 <a:cs typeface="Consolas" pitchFamily="34" charset="-120"/>
               </a:rPr>
-              <a:t>RUTAS DE LA APLICACIÓN</a:t>
+              <a:t>ASEGURADORAS INTEGRADAS</a:t>
             </a:r>
             <a:endParaRPr lang="en-US" sz="1100" dirty="0"/>
           </a:p>
@@ -3300,7 +2917,7 @@
                 <a:ea typeface="Consolas" pitchFamily="34" charset="-122"/>
                 <a:cs typeface="Consolas" pitchFamily="34" charset="-120"/>
               </a:rPr>
-              <a:t>04</a:t>
+              <a:t>03</a:t>
             </a:r>
             <a:endParaRPr lang="en-US" sz="1100" dirty="0"/>
           </a:p>
@@ -4354,6 +3971,1099 @@
                 <a:ea typeface="Consolas" pitchFamily="34" charset="-122"/>
                 <a:cs typeface="Consolas" pitchFamily="34" charset="-120"/>
               </a:rPr>
+              <a:t>04</a:t>
+            </a:r>
+            <a:endParaRPr lang="en-US" sz="1100" dirty="0"/>
+          </a:p>
+        </p:txBody>
+      </p:sp>
+      <p:sp>
+        <p:nvSpPr>
+          <p:cNvPr id="5" name="Text 3"/>
+          <p:cNvSpPr/>
+          <p:nvPr/>
+        </p:nvSpPr>
+        <p:spPr>
+          <a:xfrm>
+            <a:off x="640080" y="502920"/>
+            <a:ext cx="7863840" cy="274320"/>
+          </a:xfrm>
+          <a:prstGeom prst="rect">
+            <a:avLst/>
+          </a:prstGeom>
+          <a:noFill/>
+          <a:ln/>
+        </p:spPr>
+        <p:txBody>
+          <a:bodyPr wrap="square" rtlCol="0" anchor="ctr"/>
+          <a:lstStyle/>
+          <a:p>
+            <a:pPr indent="0" marL="0">
+              <a:buNone/>
+            </a:pPr>
+            <a:r>
+              <a:rPr lang="en-US" sz="1100" b="1" spc="200" kern="0" dirty="0">
+                <a:solidFill>
+                  <a:srgbClr val="93713D"/>
+                </a:solidFill>
+                <a:latin typeface="Consolas" pitchFamily="34" charset="0"/>
+                <a:ea typeface="Consolas" pitchFamily="34" charset="-122"/>
+                <a:cs typeface="Consolas" pitchFamily="34" charset="-120"/>
+              </a:rPr>
+              <a:t>QUÉ QUEDA REGISTRADO, EN LA PRÁCTICA</a:t>
+            </a:r>
+            <a:endParaRPr lang="en-US" sz="1100" dirty="0"/>
+          </a:p>
+        </p:txBody>
+      </p:sp>
+      <p:sp>
+        <p:nvSpPr>
+          <p:cNvPr id="6" name="Text 4"/>
+          <p:cNvSpPr/>
+          <p:nvPr/>
+        </p:nvSpPr>
+        <p:spPr>
+          <a:xfrm>
+            <a:off x="640080" y="868680"/>
+            <a:ext cx="7863840" cy="548640"/>
+          </a:xfrm>
+          <a:prstGeom prst="rect">
+            <a:avLst/>
+          </a:prstGeom>
+          <a:noFill/>
+          <a:ln/>
+        </p:spPr>
+        <p:txBody>
+          <a:bodyPr wrap="square" rtlCol="0" anchor="t"/>
+          <a:lstStyle/>
+          <a:p>
+            <a:pPr indent="0" marL="0">
+              <a:buNone/>
+            </a:pPr>
+            <a:r>
+              <a:rPr lang="en-US" sz="2200" b="1" dirty="0">
+                <a:solidFill>
+                  <a:srgbClr val="16241B"/>
+                </a:solidFill>
+                <a:latin typeface="Georgia" pitchFamily="34" charset="0"/>
+                <a:ea typeface="Georgia" pitchFamily="34" charset="-122"/>
+                <a:cs typeface="Georgia" pitchFamily="34" charset="-120"/>
+              </a:rPr>
+              <a:t>Cada dato en su lugar, listo para trabajar y auditar</a:t>
+            </a:r>
+            <a:endParaRPr lang="en-US" sz="2200" dirty="0"/>
+          </a:p>
+        </p:txBody>
+      </p:sp>
+      <p:sp>
+        <p:nvSpPr>
+          <p:cNvPr id="7" name="Text 5"/>
+          <p:cNvSpPr/>
+          <p:nvPr/>
+        </p:nvSpPr>
+        <p:spPr>
+          <a:xfrm>
+            <a:off x="640080" y="1417320"/>
+            <a:ext cx="7863840" cy="411480"/>
+          </a:xfrm>
+          <a:prstGeom prst="rect">
+            <a:avLst/>
+          </a:prstGeom>
+          <a:noFill/>
+          <a:ln/>
+        </p:spPr>
+        <p:txBody>
+          <a:bodyPr wrap="square" rtlCol="0" anchor="t"/>
+          <a:lstStyle/>
+          <a:p>
+            <a:pPr indent="0" marL="0">
+              <a:buNone/>
+            </a:pPr>
+            <a:r>
+              <a:rPr lang="en-US" sz="1300" i="1" dirty="0">
+                <a:solidFill>
+                  <a:srgbClr val="47563F"/>
+                </a:solidFill>
+                <a:latin typeface="Calibri" pitchFamily="34" charset="0"/>
+                <a:ea typeface="Calibri" pitchFamily="34" charset="-122"/>
+                <a:cs typeface="Calibri" pitchFamily="34" charset="-120"/>
+              </a:rPr>
+              <a:t>Cada operación se guarda con el detalle que el equipo necesita para trabajar el día a día y auditar después.</a:t>
+            </a:r>
+            <a:endParaRPr lang="en-US" sz="1300" dirty="0"/>
+          </a:p>
+        </p:txBody>
+      </p:sp>
+      <p:graphicFrame>
+        <p:nvGraphicFramePr>
+          <p:cNvPr id="6" name="Table 0"/>
+          <p:cNvGraphicFramePr>
+            <a:graphicFrameLocks noGrp="1"/>
+          </p:cNvGraphicFramePr>
+          <p:nvPr>
+            <p:extLst>
+              <p:ext uri="{D42A27DB-BD31-4B8C-83A1-F6EECF244321}">
+                <p14:modId xmlns:p14="http://schemas.microsoft.com/office/powerpoint/2010/main" val="1579011935"/>
+              </p:ext>
+            </p:extLst>
+          </p:nvPr>
+        </p:nvGraphicFramePr>
+        <p:xfrm>
+          <a:off x="640080" y="1920240"/>
+          <a:ext cx="7863840" cy="2971800"/>
+        </p:xfrm>
+        <a:graphic>
+          <a:graphicData uri="http://schemas.openxmlformats.org/drawingml/2006/table">
+            <a:tbl>
+              <a:tblPr/>
+              <a:tblGrid>
+                <a:gridCol w="1737360"/>
+                <a:gridCol w="6126480"/>
+              </a:tblGrid>
+              <a:tr h="495300">
+                <a:tc>
+                  <a:txBody>
+                    <a:bodyPr/>
+                    <a:lstStyle/>
+                    <a:p>
+                      <a:pPr indent="0" marL="0">
+                        <a:buNone/>
+                      </a:pPr>
+                      <a:r>
+                        <a:rPr lang="en-US" sz="1150" b="1" dirty="0">
+                          <a:solidFill>
+                            <a:srgbClr val="1A56DB"/>
+                          </a:solidFill>
+                          <a:latin typeface="Consolas" pitchFamily="34" charset="0"/>
+                          <a:ea typeface="Consolas" pitchFamily="34" charset="-122"/>
+                          <a:cs typeface="Consolas" pitchFamily="34" charset="-120"/>
+                        </a:rPr>
+                        <a:t>Asegurados</a:t>
+                      </a:r>
+                      <a:endParaRPr lang="en-US" sz="1150" dirty="0">
+                        <a:latin typeface="Consolas" charset="0"/>
+                        <a:ea typeface="Consolas" charset="0"/>
+                        <a:cs typeface="Consolas" charset="0"/>
+                      </a:endParaRPr>
+                    </a:p>
+                  </a:txBody>
+                  <a:tcPr marL="91440" marR="91440" marT="45720" marB="45720" anchor="ctr">
+                    <a:lnL w="9525" cap="flat" cmpd="sng" algn="ctr">
+                      <a:solidFill>
+                        <a:srgbClr val="A8BBA1"/>
+                      </a:solidFill>
+                      <a:prstDash val="solid"/>
+                      <a:round/>
+                      <a:headEnd type="none" w="med" len="med"/>
+                      <a:tailEnd type="none" w="med" len="med"/>
+                    </a:lnL>
+                    <a:lnR w="9525" cap="flat" cmpd="sng" algn="ctr">
+                      <a:solidFill>
+                        <a:srgbClr val="A8BBA1"/>
+                      </a:solidFill>
+                      <a:prstDash val="solid"/>
+                      <a:round/>
+                      <a:headEnd type="none" w="med" len="med"/>
+                      <a:tailEnd type="none" w="med" len="med"/>
+                    </a:lnR>
+                    <a:lnT w="9525" cap="flat" cmpd="sng" algn="ctr">
+                      <a:solidFill>
+                        <a:srgbClr val="A8BBA1"/>
+                      </a:solidFill>
+                      <a:prstDash val="solid"/>
+                      <a:round/>
+                      <a:headEnd type="none" w="med" len="med"/>
+                      <a:tailEnd type="none" w="med" len="med"/>
+                    </a:lnT>
+                    <a:lnB w="9525" cap="flat" cmpd="sng" algn="ctr">
+                      <a:solidFill>
+                        <a:srgbClr val="A8BBA1"/>
+                      </a:solidFill>
+                      <a:prstDash val="solid"/>
+                      <a:round/>
+                      <a:headEnd type="none" w="med" len="med"/>
+                      <a:tailEnd type="none" w="med" len="med"/>
+                    </a:lnB>
+                    <a:solidFill>
+                      <a:srgbClr val="E7EEE3"/>
+                    </a:solidFill>
+                  </a:tcPr>
+                </a:tc>
+                <a:tc>
+                  <a:txBody>
+                    <a:bodyPr/>
+                    <a:lstStyle/>
+                    <a:p>
+                      <a:pPr indent="0" marL="0">
+                        <a:buNone/>
+                      </a:pPr>
+                      <a:r>
+                        <a:rPr lang="en-US" sz="1150" dirty="0">
+                          <a:solidFill>
+                            <a:srgbClr val="16241B"/>
+                          </a:solidFill>
+                          <a:latin typeface="Calibri" pitchFamily="34" charset="0"/>
+                          <a:ea typeface="Calibri" pitchFamily="34" charset="-122"/>
+                          <a:cs typeface="Calibri" pitchFamily="34" charset="-120"/>
+                        </a:rPr>
+                        <a:t>Cédula, nombre, profesión, localidad, canal de captación y ejecutivo asignado.</a:t>
+                      </a:r>
+                      <a:endParaRPr lang="en-US" sz="1150" dirty="0">
+                        <a:latin typeface="Calibri" charset="0"/>
+                        <a:ea typeface="Calibri" charset="0"/>
+                        <a:cs typeface="Calibri" charset="0"/>
+                      </a:endParaRPr>
+                    </a:p>
+                  </a:txBody>
+                  <a:tcPr marL="91440" marR="91440" marT="45720" marB="45720" anchor="ctr">
+                    <a:lnL w="9525" cap="flat" cmpd="sng" algn="ctr">
+                      <a:solidFill>
+                        <a:srgbClr val="A8BBA1"/>
+                      </a:solidFill>
+                      <a:prstDash val="solid"/>
+                      <a:round/>
+                      <a:headEnd type="none" w="med" len="med"/>
+                      <a:tailEnd type="none" w="med" len="med"/>
+                    </a:lnL>
+                    <a:lnR w="9525" cap="flat" cmpd="sng" algn="ctr">
+                      <a:solidFill>
+                        <a:srgbClr val="A8BBA1"/>
+                      </a:solidFill>
+                      <a:prstDash val="solid"/>
+                      <a:round/>
+                      <a:headEnd type="none" w="med" len="med"/>
+                      <a:tailEnd type="none" w="med" len="med"/>
+                    </a:lnR>
+                    <a:lnT w="9525" cap="flat" cmpd="sng" algn="ctr">
+                      <a:solidFill>
+                        <a:srgbClr val="A8BBA1"/>
+                      </a:solidFill>
+                      <a:prstDash val="solid"/>
+                      <a:round/>
+                      <a:headEnd type="none" w="med" len="med"/>
+                      <a:tailEnd type="none" w="med" len="med"/>
+                    </a:lnT>
+                    <a:lnB w="9525" cap="flat" cmpd="sng" algn="ctr">
+                      <a:solidFill>
+                        <a:srgbClr val="A8BBA1"/>
+                      </a:solidFill>
+                      <a:prstDash val="solid"/>
+                      <a:round/>
+                      <a:headEnd type="none" w="med" len="med"/>
+                      <a:tailEnd type="none" w="med" len="med"/>
+                    </a:lnB>
+                    <a:solidFill>
+                      <a:srgbClr val="E7EEE3"/>
+                    </a:solidFill>
+                  </a:tcPr>
+                </a:tc>
+              </a:tr>
+              <a:tr h="495300">
+                <a:tc>
+                  <a:txBody>
+                    <a:bodyPr/>
+                    <a:lstStyle/>
+                    <a:p>
+                      <a:pPr indent="0" marL="0">
+                        <a:buNone/>
+                      </a:pPr>
+                      <a:r>
+                        <a:rPr lang="en-US" sz="1150" b="1" dirty="0">
+                          <a:solidFill>
+                            <a:srgbClr val="1A56DB"/>
+                          </a:solidFill>
+                          <a:latin typeface="Consolas" pitchFamily="34" charset="0"/>
+                          <a:ea typeface="Consolas" pitchFamily="34" charset="-122"/>
+                          <a:cs typeface="Consolas" pitchFamily="34" charset="-120"/>
+                        </a:rPr>
+                        <a:t>Pólizas</a:t>
+                      </a:r>
+                      <a:endParaRPr lang="en-US" sz="1150" dirty="0">
+                        <a:latin typeface="Consolas" charset="0"/>
+                        <a:ea typeface="Consolas" charset="0"/>
+                        <a:cs typeface="Consolas" charset="0"/>
+                      </a:endParaRPr>
+                    </a:p>
+                  </a:txBody>
+                  <a:tcPr marL="91440" marR="91440" marT="45720" marB="45720" anchor="ctr">
+                    <a:lnL w="9525" cap="flat" cmpd="sng" algn="ctr">
+                      <a:solidFill>
+                        <a:srgbClr val="A8BBA1"/>
+                      </a:solidFill>
+                      <a:prstDash val="solid"/>
+                      <a:round/>
+                      <a:headEnd type="none" w="med" len="med"/>
+                      <a:tailEnd type="none" w="med" len="med"/>
+                    </a:lnL>
+                    <a:lnR w="9525" cap="flat" cmpd="sng" algn="ctr">
+                      <a:solidFill>
+                        <a:srgbClr val="A8BBA1"/>
+                      </a:solidFill>
+                      <a:prstDash val="solid"/>
+                      <a:round/>
+                      <a:headEnd type="none" w="med" len="med"/>
+                      <a:tailEnd type="none" w="med" len="med"/>
+                    </a:lnR>
+                    <a:lnT w="9525" cap="flat" cmpd="sng" algn="ctr">
+                      <a:solidFill>
+                        <a:srgbClr val="A8BBA1"/>
+                      </a:solidFill>
+                      <a:prstDash val="solid"/>
+                      <a:round/>
+                      <a:headEnd type="none" w="med" len="med"/>
+                      <a:tailEnd type="none" w="med" len="med"/>
+                    </a:lnT>
+                    <a:lnB w="9525" cap="flat" cmpd="sng" algn="ctr">
+                      <a:solidFill>
+                        <a:srgbClr val="A8BBA1"/>
+                      </a:solidFill>
+                      <a:prstDash val="solid"/>
+                      <a:round/>
+                      <a:headEnd type="none" w="med" len="med"/>
+                      <a:tailEnd type="none" w="med" len="med"/>
+                    </a:lnB>
+                    <a:solidFill>
+                      <a:srgbClr val="DCE6D5"/>
+                    </a:solidFill>
+                  </a:tcPr>
+                </a:tc>
+                <a:tc>
+                  <a:txBody>
+                    <a:bodyPr/>
+                    <a:lstStyle/>
+                    <a:p>
+                      <a:pPr indent="0" marL="0">
+                        <a:buNone/>
+                      </a:pPr>
+                      <a:r>
+                        <a:rPr lang="en-US" sz="1150" dirty="0">
+                          <a:solidFill>
+                            <a:srgbClr val="16241B"/>
+                          </a:solidFill>
+                          <a:latin typeface="Calibri" pitchFamily="34" charset="0"/>
+                          <a:ea typeface="Calibri" pitchFamily="34" charset="-122"/>
+                          <a:cs typeface="Calibri" pitchFamily="34" charset="-120"/>
+                        </a:rPr>
+                        <a:t>Tipo, vigencia, prima y estado de cada cuota.</a:t>
+                      </a:r>
+                      <a:endParaRPr lang="en-US" sz="1150" dirty="0">
+                        <a:latin typeface="Calibri" charset="0"/>
+                        <a:ea typeface="Calibri" charset="0"/>
+                        <a:cs typeface="Calibri" charset="0"/>
+                      </a:endParaRPr>
+                    </a:p>
+                  </a:txBody>
+                  <a:tcPr marL="91440" marR="91440" marT="45720" marB="45720" anchor="ctr">
+                    <a:lnL w="9525" cap="flat" cmpd="sng" algn="ctr">
+                      <a:solidFill>
+                        <a:srgbClr val="A8BBA1"/>
+                      </a:solidFill>
+                      <a:prstDash val="solid"/>
+                      <a:round/>
+                      <a:headEnd type="none" w="med" len="med"/>
+                      <a:tailEnd type="none" w="med" len="med"/>
+                    </a:lnL>
+                    <a:lnR w="9525" cap="flat" cmpd="sng" algn="ctr">
+                      <a:solidFill>
+                        <a:srgbClr val="A8BBA1"/>
+                      </a:solidFill>
+                      <a:prstDash val="solid"/>
+                      <a:round/>
+                      <a:headEnd type="none" w="med" len="med"/>
+                      <a:tailEnd type="none" w="med" len="med"/>
+                    </a:lnR>
+                    <a:lnT w="9525" cap="flat" cmpd="sng" algn="ctr">
+                      <a:solidFill>
+                        <a:srgbClr val="A8BBA1"/>
+                      </a:solidFill>
+                      <a:prstDash val="solid"/>
+                      <a:round/>
+                      <a:headEnd type="none" w="med" len="med"/>
+                      <a:tailEnd type="none" w="med" len="med"/>
+                    </a:lnT>
+                    <a:lnB w="9525" cap="flat" cmpd="sng" algn="ctr">
+                      <a:solidFill>
+                        <a:srgbClr val="A8BBA1"/>
+                      </a:solidFill>
+                      <a:prstDash val="solid"/>
+                      <a:round/>
+                      <a:headEnd type="none" w="med" len="med"/>
+                      <a:tailEnd type="none" w="med" len="med"/>
+                    </a:lnB>
+                    <a:solidFill>
+                      <a:srgbClr val="DCE6D5"/>
+                    </a:solidFill>
+                  </a:tcPr>
+                </a:tc>
+              </a:tr>
+              <a:tr h="495300">
+                <a:tc>
+                  <a:txBody>
+                    <a:bodyPr/>
+                    <a:lstStyle/>
+                    <a:p>
+                      <a:pPr indent="0" marL="0">
+                        <a:buNone/>
+                      </a:pPr>
+                      <a:r>
+                        <a:rPr lang="en-US" sz="1150" b="1" dirty="0">
+                          <a:solidFill>
+                            <a:srgbClr val="1A56DB"/>
+                          </a:solidFill>
+                          <a:latin typeface="Consolas" pitchFamily="34" charset="0"/>
+                          <a:ea typeface="Consolas" pitchFamily="34" charset="-122"/>
+                          <a:cs typeface="Consolas" pitchFamily="34" charset="-120"/>
+                        </a:rPr>
+                        <a:t>Pagos</a:t>
+                      </a:r>
+                      <a:endParaRPr lang="en-US" sz="1150" dirty="0">
+                        <a:latin typeface="Consolas" charset="0"/>
+                        <a:ea typeface="Consolas" charset="0"/>
+                        <a:cs typeface="Consolas" charset="0"/>
+                      </a:endParaRPr>
+                    </a:p>
+                  </a:txBody>
+                  <a:tcPr marL="91440" marR="91440" marT="45720" marB="45720" anchor="ctr">
+                    <a:lnL w="9525" cap="flat" cmpd="sng" algn="ctr">
+                      <a:solidFill>
+                        <a:srgbClr val="A8BBA1"/>
+                      </a:solidFill>
+                      <a:prstDash val="solid"/>
+                      <a:round/>
+                      <a:headEnd type="none" w="med" len="med"/>
+                      <a:tailEnd type="none" w="med" len="med"/>
+                    </a:lnL>
+                    <a:lnR w="9525" cap="flat" cmpd="sng" algn="ctr">
+                      <a:solidFill>
+                        <a:srgbClr val="A8BBA1"/>
+                      </a:solidFill>
+                      <a:prstDash val="solid"/>
+                      <a:round/>
+                      <a:headEnd type="none" w="med" len="med"/>
+                      <a:tailEnd type="none" w="med" len="med"/>
+                    </a:lnR>
+                    <a:lnT w="9525" cap="flat" cmpd="sng" algn="ctr">
+                      <a:solidFill>
+                        <a:srgbClr val="A8BBA1"/>
+                      </a:solidFill>
+                      <a:prstDash val="solid"/>
+                      <a:round/>
+                      <a:headEnd type="none" w="med" len="med"/>
+                      <a:tailEnd type="none" w="med" len="med"/>
+                    </a:lnT>
+                    <a:lnB w="9525" cap="flat" cmpd="sng" algn="ctr">
+                      <a:solidFill>
+                        <a:srgbClr val="A8BBA1"/>
+                      </a:solidFill>
+                      <a:prstDash val="solid"/>
+                      <a:round/>
+                      <a:headEnd type="none" w="med" len="med"/>
+                      <a:tailEnd type="none" w="med" len="med"/>
+                    </a:lnB>
+                    <a:solidFill>
+                      <a:srgbClr val="E7EEE3"/>
+                    </a:solidFill>
+                  </a:tcPr>
+                </a:tc>
+                <a:tc>
+                  <a:txBody>
+                    <a:bodyPr/>
+                    <a:lstStyle/>
+                    <a:p>
+                      <a:pPr indent="0" marL="0">
+                        <a:buNone/>
+                      </a:pPr>
+                      <a:r>
+                        <a:rPr lang="en-US" sz="1150" dirty="0">
+                          <a:solidFill>
+                            <a:srgbClr val="16241B"/>
+                          </a:solidFill>
+                          <a:latin typeface="Calibri" pitchFamily="34" charset="0"/>
+                          <a:ea typeface="Calibri" pitchFamily="34" charset="-122"/>
+                          <a:cs typeface="Calibri" pitchFamily="34" charset="-120"/>
+                        </a:rPr>
+                        <a:t>Fecha, monto, moneda, tasa de cambio y método.</a:t>
+                      </a:r>
+                      <a:endParaRPr lang="en-US" sz="1150" dirty="0">
+                        <a:latin typeface="Calibri" charset="0"/>
+                        <a:ea typeface="Calibri" charset="0"/>
+                        <a:cs typeface="Calibri" charset="0"/>
+                      </a:endParaRPr>
+                    </a:p>
+                  </a:txBody>
+                  <a:tcPr marL="91440" marR="91440" marT="45720" marB="45720" anchor="ctr">
+                    <a:lnL w="9525" cap="flat" cmpd="sng" algn="ctr">
+                      <a:solidFill>
+                        <a:srgbClr val="A8BBA1"/>
+                      </a:solidFill>
+                      <a:prstDash val="solid"/>
+                      <a:round/>
+                      <a:headEnd type="none" w="med" len="med"/>
+                      <a:tailEnd type="none" w="med" len="med"/>
+                    </a:lnL>
+                    <a:lnR w="9525" cap="flat" cmpd="sng" algn="ctr">
+                      <a:solidFill>
+                        <a:srgbClr val="A8BBA1"/>
+                      </a:solidFill>
+                      <a:prstDash val="solid"/>
+                      <a:round/>
+                      <a:headEnd type="none" w="med" len="med"/>
+                      <a:tailEnd type="none" w="med" len="med"/>
+                    </a:lnR>
+                    <a:lnT w="9525" cap="flat" cmpd="sng" algn="ctr">
+                      <a:solidFill>
+                        <a:srgbClr val="A8BBA1"/>
+                      </a:solidFill>
+                      <a:prstDash val="solid"/>
+                      <a:round/>
+                      <a:headEnd type="none" w="med" len="med"/>
+                      <a:tailEnd type="none" w="med" len="med"/>
+                    </a:lnT>
+                    <a:lnB w="9525" cap="flat" cmpd="sng" algn="ctr">
+                      <a:solidFill>
+                        <a:srgbClr val="A8BBA1"/>
+                      </a:solidFill>
+                      <a:prstDash val="solid"/>
+                      <a:round/>
+                      <a:headEnd type="none" w="med" len="med"/>
+                      <a:tailEnd type="none" w="med" len="med"/>
+                    </a:lnB>
+                    <a:solidFill>
+                      <a:srgbClr val="E7EEE3"/>
+                    </a:solidFill>
+                  </a:tcPr>
+                </a:tc>
+              </a:tr>
+              <a:tr h="495300">
+                <a:tc>
+                  <a:txBody>
+                    <a:bodyPr/>
+                    <a:lstStyle/>
+                    <a:p>
+                      <a:pPr indent="0" marL="0">
+                        <a:buNone/>
+                      </a:pPr>
+                      <a:r>
+                        <a:rPr lang="en-US" sz="1150" b="1" dirty="0">
+                          <a:solidFill>
+                            <a:srgbClr val="1A56DB"/>
+                          </a:solidFill>
+                          <a:latin typeface="Consolas" pitchFamily="34" charset="0"/>
+                          <a:ea typeface="Consolas" pitchFamily="34" charset="-122"/>
+                          <a:cs typeface="Consolas" pitchFamily="34" charset="-120"/>
+                        </a:rPr>
+                        <a:t>Comisiones</a:t>
+                      </a:r>
+                      <a:endParaRPr lang="en-US" sz="1150" dirty="0">
+                        <a:latin typeface="Consolas" charset="0"/>
+                        <a:ea typeface="Consolas" charset="0"/>
+                        <a:cs typeface="Consolas" charset="0"/>
+                      </a:endParaRPr>
+                    </a:p>
+                  </a:txBody>
+                  <a:tcPr marL="91440" marR="91440" marT="45720" marB="45720" anchor="ctr">
+                    <a:lnL w="9525" cap="flat" cmpd="sng" algn="ctr">
+                      <a:solidFill>
+                        <a:srgbClr val="A8BBA1"/>
+                      </a:solidFill>
+                      <a:prstDash val="solid"/>
+                      <a:round/>
+                      <a:headEnd type="none" w="med" len="med"/>
+                      <a:tailEnd type="none" w="med" len="med"/>
+                    </a:lnL>
+                    <a:lnR w="9525" cap="flat" cmpd="sng" algn="ctr">
+                      <a:solidFill>
+                        <a:srgbClr val="A8BBA1"/>
+                      </a:solidFill>
+                      <a:prstDash val="solid"/>
+                      <a:round/>
+                      <a:headEnd type="none" w="med" len="med"/>
+                      <a:tailEnd type="none" w="med" len="med"/>
+                    </a:lnR>
+                    <a:lnT w="9525" cap="flat" cmpd="sng" algn="ctr">
+                      <a:solidFill>
+                        <a:srgbClr val="A8BBA1"/>
+                      </a:solidFill>
+                      <a:prstDash val="solid"/>
+                      <a:round/>
+                      <a:headEnd type="none" w="med" len="med"/>
+                      <a:tailEnd type="none" w="med" len="med"/>
+                    </a:lnT>
+                    <a:lnB w="9525" cap="flat" cmpd="sng" algn="ctr">
+                      <a:solidFill>
+                        <a:srgbClr val="A8BBA1"/>
+                      </a:solidFill>
+                      <a:prstDash val="solid"/>
+                      <a:round/>
+                      <a:headEnd type="none" w="med" len="med"/>
+                      <a:tailEnd type="none" w="med" len="med"/>
+                    </a:lnB>
+                    <a:solidFill>
+                      <a:srgbClr val="DCE6D5"/>
+                    </a:solidFill>
+                  </a:tcPr>
+                </a:tc>
+                <a:tc>
+                  <a:txBody>
+                    <a:bodyPr/>
+                    <a:lstStyle/>
+                    <a:p>
+                      <a:pPr indent="0" marL="0">
+                        <a:buNone/>
+                      </a:pPr>
+                      <a:r>
+                        <a:rPr lang="en-US" sz="1150" dirty="0">
+                          <a:solidFill>
+                            <a:srgbClr val="16241B"/>
+                          </a:solidFill>
+                          <a:latin typeface="Calibri" pitchFamily="34" charset="0"/>
+                          <a:ea typeface="Calibri" pitchFamily="34" charset="-122"/>
+                          <a:cs typeface="Calibri" pitchFamily="34" charset="-120"/>
+                        </a:rPr>
+                        <a:t>Monto recibido, aseguradora, ejecutivo y póliza asociada.</a:t>
+                      </a:r>
+                      <a:endParaRPr lang="en-US" sz="1150" dirty="0">
+                        <a:latin typeface="Calibri" charset="0"/>
+                        <a:ea typeface="Calibri" charset="0"/>
+                        <a:cs typeface="Calibri" charset="0"/>
+                      </a:endParaRPr>
+                    </a:p>
+                  </a:txBody>
+                  <a:tcPr marL="91440" marR="91440" marT="45720" marB="45720" anchor="ctr">
+                    <a:lnL w="9525" cap="flat" cmpd="sng" algn="ctr">
+                      <a:solidFill>
+                        <a:srgbClr val="A8BBA1"/>
+                      </a:solidFill>
+                      <a:prstDash val="solid"/>
+                      <a:round/>
+                      <a:headEnd type="none" w="med" len="med"/>
+                      <a:tailEnd type="none" w="med" len="med"/>
+                    </a:lnL>
+                    <a:lnR w="9525" cap="flat" cmpd="sng" algn="ctr">
+                      <a:solidFill>
+                        <a:srgbClr val="A8BBA1"/>
+                      </a:solidFill>
+                      <a:prstDash val="solid"/>
+                      <a:round/>
+                      <a:headEnd type="none" w="med" len="med"/>
+                      <a:tailEnd type="none" w="med" len="med"/>
+                    </a:lnR>
+                    <a:lnT w="9525" cap="flat" cmpd="sng" algn="ctr">
+                      <a:solidFill>
+                        <a:srgbClr val="A8BBA1"/>
+                      </a:solidFill>
+                      <a:prstDash val="solid"/>
+                      <a:round/>
+                      <a:headEnd type="none" w="med" len="med"/>
+                      <a:tailEnd type="none" w="med" len="med"/>
+                    </a:lnT>
+                    <a:lnB w="9525" cap="flat" cmpd="sng" algn="ctr">
+                      <a:solidFill>
+                        <a:srgbClr val="A8BBA1"/>
+                      </a:solidFill>
+                      <a:prstDash val="solid"/>
+                      <a:round/>
+                      <a:headEnd type="none" w="med" len="med"/>
+                      <a:tailEnd type="none" w="med" len="med"/>
+                    </a:lnB>
+                    <a:solidFill>
+                      <a:srgbClr val="DCE6D5"/>
+                    </a:solidFill>
+                  </a:tcPr>
+                </a:tc>
+              </a:tr>
+              <a:tr h="495300">
+                <a:tc>
+                  <a:txBody>
+                    <a:bodyPr/>
+                    <a:lstStyle/>
+                    <a:p>
+                      <a:pPr indent="0" marL="0">
+                        <a:buNone/>
+                      </a:pPr>
+                      <a:r>
+                        <a:rPr lang="en-US" sz="1150" b="1" dirty="0">
+                          <a:solidFill>
+                            <a:srgbClr val="1A56DB"/>
+                          </a:solidFill>
+                          <a:latin typeface="Consolas" pitchFamily="34" charset="0"/>
+                          <a:ea typeface="Consolas" pitchFamily="34" charset="-122"/>
+                          <a:cs typeface="Consolas" pitchFamily="34" charset="-120"/>
+                        </a:rPr>
+                        <a:t>Siniestros</a:t>
+                      </a:r>
+                      <a:endParaRPr lang="en-US" sz="1150" dirty="0">
+                        <a:latin typeface="Consolas" charset="0"/>
+                        <a:ea typeface="Consolas" charset="0"/>
+                        <a:cs typeface="Consolas" charset="0"/>
+                      </a:endParaRPr>
+                    </a:p>
+                  </a:txBody>
+                  <a:tcPr marL="91440" marR="91440" marT="45720" marB="45720" anchor="ctr">
+                    <a:lnL w="9525" cap="flat" cmpd="sng" algn="ctr">
+                      <a:solidFill>
+                        <a:srgbClr val="A8BBA1"/>
+                      </a:solidFill>
+                      <a:prstDash val="solid"/>
+                      <a:round/>
+                      <a:headEnd type="none" w="med" len="med"/>
+                      <a:tailEnd type="none" w="med" len="med"/>
+                    </a:lnL>
+                    <a:lnR w="9525" cap="flat" cmpd="sng" algn="ctr">
+                      <a:solidFill>
+                        <a:srgbClr val="A8BBA1"/>
+                      </a:solidFill>
+                      <a:prstDash val="solid"/>
+                      <a:round/>
+                      <a:headEnd type="none" w="med" len="med"/>
+                      <a:tailEnd type="none" w="med" len="med"/>
+                    </a:lnR>
+                    <a:lnT w="9525" cap="flat" cmpd="sng" algn="ctr">
+                      <a:solidFill>
+                        <a:srgbClr val="A8BBA1"/>
+                      </a:solidFill>
+                      <a:prstDash val="solid"/>
+                      <a:round/>
+                      <a:headEnd type="none" w="med" len="med"/>
+                      <a:tailEnd type="none" w="med" len="med"/>
+                    </a:lnT>
+                    <a:lnB w="9525" cap="flat" cmpd="sng" algn="ctr">
+                      <a:solidFill>
+                        <a:srgbClr val="A8BBA1"/>
+                      </a:solidFill>
+                      <a:prstDash val="solid"/>
+                      <a:round/>
+                      <a:headEnd type="none" w="med" len="med"/>
+                      <a:tailEnd type="none" w="med" len="med"/>
+                    </a:lnB>
+                    <a:solidFill>
+                      <a:srgbClr val="E7EEE3"/>
+                    </a:solidFill>
+                  </a:tcPr>
+                </a:tc>
+                <a:tc>
+                  <a:txBody>
+                    <a:bodyPr/>
+                    <a:lstStyle/>
+                    <a:p>
+                      <a:pPr indent="0" marL="0">
+                        <a:buNone/>
+                      </a:pPr>
+                      <a:r>
+                        <a:rPr lang="en-US" sz="1150" dirty="0">
+                          <a:solidFill>
+                            <a:srgbClr val="16241B"/>
+                          </a:solidFill>
+                          <a:latin typeface="Calibri" pitchFamily="34" charset="0"/>
+                          <a:ea typeface="Calibri" pitchFamily="34" charset="-122"/>
+                          <a:cs typeface="Calibri" pitchFamily="34" charset="-120"/>
+                        </a:rPr>
+                        <a:t>Tipo de reclamación, notas de seguimiento y estado.</a:t>
+                      </a:r>
+                      <a:endParaRPr lang="en-US" sz="1150" dirty="0">
+                        <a:latin typeface="Calibri" charset="0"/>
+                        <a:ea typeface="Calibri" charset="0"/>
+                        <a:cs typeface="Calibri" charset="0"/>
+                      </a:endParaRPr>
+                    </a:p>
+                  </a:txBody>
+                  <a:tcPr marL="91440" marR="91440" marT="45720" marB="45720" anchor="ctr">
+                    <a:lnL w="9525" cap="flat" cmpd="sng" algn="ctr">
+                      <a:solidFill>
+                        <a:srgbClr val="A8BBA1"/>
+                      </a:solidFill>
+                      <a:prstDash val="solid"/>
+                      <a:round/>
+                      <a:headEnd type="none" w="med" len="med"/>
+                      <a:tailEnd type="none" w="med" len="med"/>
+                    </a:lnL>
+                    <a:lnR w="9525" cap="flat" cmpd="sng" algn="ctr">
+                      <a:solidFill>
+                        <a:srgbClr val="A8BBA1"/>
+                      </a:solidFill>
+                      <a:prstDash val="solid"/>
+                      <a:round/>
+                      <a:headEnd type="none" w="med" len="med"/>
+                      <a:tailEnd type="none" w="med" len="med"/>
+                    </a:lnR>
+                    <a:lnT w="9525" cap="flat" cmpd="sng" algn="ctr">
+                      <a:solidFill>
+                        <a:srgbClr val="A8BBA1"/>
+                      </a:solidFill>
+                      <a:prstDash val="solid"/>
+                      <a:round/>
+                      <a:headEnd type="none" w="med" len="med"/>
+                      <a:tailEnd type="none" w="med" len="med"/>
+                    </a:lnT>
+                    <a:lnB w="9525" cap="flat" cmpd="sng" algn="ctr">
+                      <a:solidFill>
+                        <a:srgbClr val="A8BBA1"/>
+                      </a:solidFill>
+                      <a:prstDash val="solid"/>
+                      <a:round/>
+                      <a:headEnd type="none" w="med" len="med"/>
+                      <a:tailEnd type="none" w="med" len="med"/>
+                    </a:lnB>
+                    <a:solidFill>
+                      <a:srgbClr val="E7EEE3"/>
+                    </a:solidFill>
+                  </a:tcPr>
+                </a:tc>
+              </a:tr>
+              <a:tr h="495300">
+                <a:tc>
+                  <a:txBody>
+                    <a:bodyPr/>
+                    <a:lstStyle/>
+                    <a:p>
+                      <a:pPr indent="0" marL="0">
+                        <a:buNone/>
+                      </a:pPr>
+                      <a:r>
+                        <a:rPr lang="en-US" sz="1150" b="1" dirty="0">
+                          <a:solidFill>
+                            <a:srgbClr val="1A56DB"/>
+                          </a:solidFill>
+                          <a:latin typeface="Consolas" pitchFamily="34" charset="0"/>
+                          <a:ea typeface="Consolas" pitchFamily="34" charset="-122"/>
+                          <a:cs typeface="Consolas" pitchFamily="34" charset="-120"/>
+                        </a:rPr>
+                        <a:t>Reportes</a:t>
+                      </a:r>
+                      <a:endParaRPr lang="en-US" sz="1150" dirty="0">
+                        <a:latin typeface="Consolas" charset="0"/>
+                        <a:ea typeface="Consolas" charset="0"/>
+                        <a:cs typeface="Consolas" charset="0"/>
+                      </a:endParaRPr>
+                    </a:p>
+                  </a:txBody>
+                  <a:tcPr marL="91440" marR="91440" marT="45720" marB="45720" anchor="ctr">
+                    <a:lnL w="9525" cap="flat" cmpd="sng" algn="ctr">
+                      <a:solidFill>
+                        <a:srgbClr val="A8BBA1"/>
+                      </a:solidFill>
+                      <a:prstDash val="solid"/>
+                      <a:round/>
+                      <a:headEnd type="none" w="med" len="med"/>
+                      <a:tailEnd type="none" w="med" len="med"/>
+                    </a:lnL>
+                    <a:lnR w="9525" cap="flat" cmpd="sng" algn="ctr">
+                      <a:solidFill>
+                        <a:srgbClr val="A8BBA1"/>
+                      </a:solidFill>
+                      <a:prstDash val="solid"/>
+                      <a:round/>
+                      <a:headEnd type="none" w="med" len="med"/>
+                      <a:tailEnd type="none" w="med" len="med"/>
+                    </a:lnR>
+                    <a:lnT w="9525" cap="flat" cmpd="sng" algn="ctr">
+                      <a:solidFill>
+                        <a:srgbClr val="A8BBA1"/>
+                      </a:solidFill>
+                      <a:prstDash val="solid"/>
+                      <a:round/>
+                      <a:headEnd type="none" w="med" len="med"/>
+                      <a:tailEnd type="none" w="med" len="med"/>
+                    </a:lnT>
+                    <a:lnB w="9525" cap="flat" cmpd="sng" algn="ctr">
+                      <a:solidFill>
+                        <a:srgbClr val="A8BBA1"/>
+                      </a:solidFill>
+                      <a:prstDash val="solid"/>
+                      <a:round/>
+                      <a:headEnd type="none" w="med" len="med"/>
+                      <a:tailEnd type="none" w="med" len="med"/>
+                    </a:lnB>
+                    <a:solidFill>
+                      <a:srgbClr val="DCE6D5"/>
+                    </a:solidFill>
+                  </a:tcPr>
+                </a:tc>
+                <a:tc>
+                  <a:txBody>
+                    <a:bodyPr/>
+                    <a:lstStyle/>
+                    <a:p>
+                      <a:pPr indent="0" marL="0">
+                        <a:buNone/>
+                      </a:pPr>
+                      <a:r>
+                        <a:rPr lang="en-US" sz="1150" dirty="0">
+                          <a:solidFill>
+                            <a:srgbClr val="16241B"/>
+                          </a:solidFill>
+                          <a:latin typeface="Calibri" pitchFamily="34" charset="0"/>
+                          <a:ea typeface="Calibri" pitchFamily="34" charset="-122"/>
+                          <a:cs typeface="Calibri" pitchFamily="34" charset="-120"/>
+                        </a:rPr>
+                        <a:t>Consolidado por ejecutivo, dashboard de negocio y reporte regulatorio Sudaseg.</a:t>
+                      </a:r>
+                      <a:endParaRPr lang="en-US" sz="1150" dirty="0">
+                        <a:latin typeface="Calibri" charset="0"/>
+                        <a:ea typeface="Calibri" charset="0"/>
+                        <a:cs typeface="Calibri" charset="0"/>
+                      </a:endParaRPr>
+                    </a:p>
+                  </a:txBody>
+                  <a:tcPr marL="91440" marR="91440" marT="45720" marB="45720" anchor="ctr">
+                    <a:lnL w="9525" cap="flat" cmpd="sng" algn="ctr">
+                      <a:solidFill>
+                        <a:srgbClr val="A8BBA1"/>
+                      </a:solidFill>
+                      <a:prstDash val="solid"/>
+                      <a:round/>
+                      <a:headEnd type="none" w="med" len="med"/>
+                      <a:tailEnd type="none" w="med" len="med"/>
+                    </a:lnL>
+                    <a:lnR w="9525" cap="flat" cmpd="sng" algn="ctr">
+                      <a:solidFill>
+                        <a:srgbClr val="A8BBA1"/>
+                      </a:solidFill>
+                      <a:prstDash val="solid"/>
+                      <a:round/>
+                      <a:headEnd type="none" w="med" len="med"/>
+                      <a:tailEnd type="none" w="med" len="med"/>
+                    </a:lnR>
+                    <a:lnT w="9525" cap="flat" cmpd="sng" algn="ctr">
+                      <a:solidFill>
+                        <a:srgbClr val="A8BBA1"/>
+                      </a:solidFill>
+                      <a:prstDash val="solid"/>
+                      <a:round/>
+                      <a:headEnd type="none" w="med" len="med"/>
+                      <a:tailEnd type="none" w="med" len="med"/>
+                    </a:lnT>
+                    <a:lnB w="9525" cap="flat" cmpd="sng" algn="ctr">
+                      <a:solidFill>
+                        <a:srgbClr val="A8BBA1"/>
+                      </a:solidFill>
+                      <a:prstDash val="solid"/>
+                      <a:round/>
+                      <a:headEnd type="none" w="med" len="med"/>
+                      <a:tailEnd type="none" w="med" len="med"/>
+                    </a:lnB>
+                    <a:solidFill>
+                      <a:srgbClr val="DCE6D5"/>
+                    </a:solidFill>
+                  </a:tcPr>
+                </a:tc>
+              </a:tr>
+            </a:tbl>
+          </a:graphicData>
+        </a:graphic>
+      </p:graphicFrame>
+    </p:spTree>
+  </p:cSld>
+  <p:clrMapOvr>
+    <a:masterClrMapping/>
+  </p:clrMapOvr>
+</p:sld>
+</file>
+
+<file path=ppt/slides/slide6.xml><?xml version="1.0" encoding="utf-8"?>
+<p:sld xmlns:a="http://schemas.openxmlformats.org/drawingml/2006/main" xmlns:r="http://schemas.openxmlformats.org/officeDocument/2006/relationships" xmlns:p="http://schemas.openxmlformats.org/presentationml/2006/main">
+  <p:cSld name="Slide 6">
+    <p:bg>
+      <p:bgPr>
+        <a:solidFill>
+          <a:srgbClr val="E7EEE3"/>
+        </a:solidFill>
+      </p:bgPr>
+    </p:bg>
+    <p:spTree>
+      <p:nvGrpSpPr>
+        <p:cNvPr id="1" name=""/>
+        <p:cNvGrpSpPr/>
+        <p:nvPr/>
+      </p:nvGrpSpPr>
+      <p:grpSpPr>
+        <a:xfrm>
+          <a:off x="0" y="0"/>
+          <a:ext cx="0" cy="0"/>
+          <a:chOff x="0" y="0"/>
+          <a:chExt cx="0" cy="0"/>
+        </a:xfrm>
+      </p:grpSpPr>
+      <p:sp>
+        <p:nvSpPr>
+          <p:cNvPr id="2" name="Shape 0"/>
+          <p:cNvSpPr/>
+          <p:nvPr/>
+        </p:nvSpPr>
+        <p:spPr>
+          <a:xfrm>
+            <a:off x="109728" y="109728"/>
+            <a:ext cx="8924544" cy="4928616"/>
+          </a:xfrm>
+          <a:prstGeom prst="rect">
+            <a:avLst/>
+          </a:prstGeom>
+          <a:ln w="12700">
+            <a:solidFill>
+              <a:srgbClr val="A8BBA1"/>
+            </a:solidFill>
+            <a:prstDash val="solid"/>
+          </a:ln>
+        </p:spPr>
+      </p:sp>
+      <p:sp>
+        <p:nvSpPr>
+          <p:cNvPr id="3" name="Shape 1"/>
+          <p:cNvSpPr/>
+          <p:nvPr/>
+        </p:nvSpPr>
+        <p:spPr>
+          <a:xfrm>
+            <a:off x="109728" y="109728"/>
+            <a:ext cx="512064" cy="310896"/>
+          </a:xfrm>
+          <a:prstGeom prst="rect">
+            <a:avLst/>
+          </a:prstGeom>
+          <a:solidFill>
+            <a:srgbClr val="DCE6D5"/>
+          </a:solidFill>
+          <a:ln w="12700">
+            <a:solidFill>
+              <a:srgbClr val="A8BBA1"/>
+            </a:solidFill>
+            <a:prstDash val="solid"/>
+          </a:ln>
+        </p:spPr>
+      </p:sp>
+      <p:sp>
+        <p:nvSpPr>
+          <p:cNvPr id="4" name="Text 2"/>
+          <p:cNvSpPr/>
+          <p:nvPr/>
+        </p:nvSpPr>
+        <p:spPr>
+          <a:xfrm>
+            <a:off x="109728" y="109728"/>
+            <a:ext cx="512064" cy="310896"/>
+          </a:xfrm>
+          <a:prstGeom prst="rect">
+            <a:avLst/>
+          </a:prstGeom>
+          <a:noFill/>
+          <a:ln/>
+        </p:spPr>
+        <p:txBody>
+          <a:bodyPr wrap="square" rtlCol="0" anchor="ctr"/>
+          <a:lstStyle/>
+          <a:p>
+            <a:pPr algn="ctr" indent="0" marL="0">
+              <a:buNone/>
+            </a:pPr>
+            <a:r>
+              <a:rPr lang="en-US" sz="1100" b="1" dirty="0">
+                <a:solidFill>
+                  <a:srgbClr val="93713D"/>
+                </a:solidFill>
+                <a:latin typeface="Consolas" pitchFamily="34" charset="0"/>
+                <a:ea typeface="Consolas" pitchFamily="34" charset="-122"/>
+                <a:cs typeface="Consolas" pitchFamily="34" charset="-120"/>
+              </a:rPr>
               <a:t>05</a:t>
             </a:r>
             <a:endParaRPr lang="en-US" sz="1100" dirty="0"/>
@@ -4408,7 +5118,7 @@
         <p:spPr>
           <a:xfrm>
             <a:off x="640080" y="868680"/>
-            <a:ext cx="7863840" cy="640080"/>
+            <a:ext cx="7863840" cy="502920"/>
           </a:xfrm>
           <a:prstGeom prst="rect">
             <a:avLst/>
@@ -4424,7 +5134,7 @@
               <a:buNone/>
             </a:pPr>
             <a:r>
-              <a:rPr lang="en-US" sz="2800" b="1" dirty="0">
+              <a:rPr lang="en-US" sz="3000" b="1" dirty="0">
                 <a:solidFill>
                   <a:srgbClr val="16241B"/>
                 </a:solidFill>
@@ -4432,9 +5142,9 @@
                 <a:ea typeface="Georgia" pitchFamily="34" charset="-122"/>
                 <a:cs typeface="Georgia" pitchFamily="34" charset="-120"/>
               </a:rPr>
-              <a:t>Simple y directa, a propósito</a:t>
+              <a:t>Simple y directa</a:t>
             </a:r>
-            <a:endParaRPr lang="en-US" sz="2800" dirty="0"/>
+            <a:endParaRPr lang="en-US" sz="3000" dirty="0"/>
           </a:p>
         </p:txBody>
       </p:sp>
@@ -4446,8 +5156,8 @@
         </p:nvSpPr>
         <p:spPr>
           <a:xfrm>
-            <a:off x="640080" y="1554480"/>
-            <a:ext cx="7863840" cy="365760"/>
+            <a:off x="640080" y="1371600"/>
+            <a:ext cx="7863840" cy="594360"/>
           </a:xfrm>
           <a:prstGeom prst="rect">
             <a:avLst/>
@@ -4456,24 +5166,24 @@
           <a:ln/>
         </p:spPr>
         <p:txBody>
-          <a:bodyPr wrap="square" rtlCol="0" anchor="ctr"/>
+          <a:bodyPr wrap="square" rtlCol="0" anchor="t"/>
           <a:lstStyle/>
           <a:p>
             <a:pPr indent="0" marL="0">
               <a:buNone/>
             </a:pPr>
             <a:r>
-              <a:rPr lang="en-US" sz="1300" b="1" dirty="0">
+              <a:rPr lang="en-US" sz="1350" dirty="0">
                 <a:solidFill>
-                  <a:srgbClr val="93713D"/>
+                  <a:srgbClr val="47563F"/>
                 </a:solidFill>
-                <a:latin typeface="Consolas" pitchFamily="34" charset="0"/>
-                <a:ea typeface="Consolas" pitchFamily="34" charset="-122"/>
-                <a:cs typeface="Consolas" pitchFamily="34" charset="-120"/>
+                <a:latin typeface="Calibri" pitchFamily="34" charset="0"/>
+                <a:ea typeface="Calibri" pitchFamily="34" charset="-122"/>
+                <a:cs typeface="Calibri" pitchFamily="34" charset="-120"/>
               </a:rPr>
-              <a:t>Flask + PyMySQL + MySQL/TiDB Cloud + Jinja2/Bootstrap</a:t>
+              <a:t>Cada acción del usuario recorre el mismo camino, sin atajos: se valida, se guarda y queda disponible al instante para todo el equipo.</a:t>
             </a:r>
-            <a:endParaRPr lang="en-US" sz="1300" dirty="0"/>
+            <a:endParaRPr lang="en-US" sz="1350" dirty="0"/>
           </a:p>
         </p:txBody>
       </p:sp>
@@ -4485,8 +5195,8 @@
         </p:nvSpPr>
         <p:spPr>
           <a:xfrm>
-            <a:off x="699516" y="2331720"/>
-            <a:ext cx="1417320" cy="914400"/>
+            <a:off x="699516" y="2057400"/>
+            <a:ext cx="1417320" cy="777240"/>
           </a:xfrm>
           <a:prstGeom prst="rect">
             <a:avLst/>
@@ -4510,8 +5220,8 @@
         </p:nvSpPr>
         <p:spPr>
           <a:xfrm>
-            <a:off x="699516" y="2331720"/>
-            <a:ext cx="1417320" cy="914400"/>
+            <a:off x="699516" y="2057400"/>
+            <a:ext cx="1417320" cy="777240"/>
           </a:xfrm>
           <a:prstGeom prst="rect">
             <a:avLst/>
@@ -4549,7 +5259,7 @@
         </p:nvSpPr>
         <p:spPr>
           <a:xfrm>
-            <a:off x="2116836" y="2788920"/>
+            <a:off x="2116836" y="2446020"/>
             <a:ext cx="164592" cy="0"/>
           </a:xfrm>
           <a:prstGeom prst="line">
@@ -4573,8 +5283,8 @@
         </p:nvSpPr>
         <p:spPr>
           <a:xfrm>
-            <a:off x="2281428" y="2331720"/>
-            <a:ext cx="1417320" cy="914400"/>
+            <a:off x="2281428" y="2057400"/>
+            <a:ext cx="1417320" cy="777240"/>
           </a:xfrm>
           <a:prstGeom prst="rect">
             <a:avLst/>
@@ -4598,8 +5308,8 @@
         </p:nvSpPr>
         <p:spPr>
           <a:xfrm>
-            <a:off x="2281428" y="2331720"/>
-            <a:ext cx="1417320" cy="914400"/>
+            <a:off x="2281428" y="2057400"/>
+            <a:ext cx="1417320" cy="777240"/>
           </a:xfrm>
           <a:prstGeom prst="rect">
             <a:avLst/>
@@ -4654,7 +5364,7 @@
         </p:nvSpPr>
         <p:spPr>
           <a:xfrm>
-            <a:off x="3698748" y="2788920"/>
+            <a:off x="3698748" y="2446020"/>
             <a:ext cx="164592" cy="0"/>
           </a:xfrm>
           <a:prstGeom prst="line">
@@ -4678,8 +5388,8 @@
         </p:nvSpPr>
         <p:spPr>
           <a:xfrm>
-            <a:off x="3863340" y="2331720"/>
-            <a:ext cx="1417320" cy="914400"/>
+            <a:off x="3863340" y="2057400"/>
+            <a:ext cx="1417320" cy="777240"/>
           </a:xfrm>
           <a:prstGeom prst="rect">
             <a:avLst/>
@@ -4703,8 +5413,8 @@
         </p:nvSpPr>
         <p:spPr>
           <a:xfrm>
-            <a:off x="3863340" y="2331720"/>
-            <a:ext cx="1417320" cy="914400"/>
+            <a:off x="3863340" y="2057400"/>
+            <a:ext cx="1417320" cy="777240"/>
           </a:xfrm>
           <a:prstGeom prst="rect">
             <a:avLst/>
@@ -4742,7 +5452,7 @@
         </p:nvSpPr>
         <p:spPr>
           <a:xfrm>
-            <a:off x="5280660" y="2788920"/>
+            <a:off x="5280660" y="2446020"/>
             <a:ext cx="164592" cy="0"/>
           </a:xfrm>
           <a:prstGeom prst="line">
@@ -4766,8 +5476,8 @@
         </p:nvSpPr>
         <p:spPr>
           <a:xfrm>
-            <a:off x="5445252" y="2331720"/>
-            <a:ext cx="1417320" cy="914400"/>
+            <a:off x="5445252" y="2057400"/>
+            <a:ext cx="1417320" cy="777240"/>
           </a:xfrm>
           <a:prstGeom prst="rect">
             <a:avLst/>
@@ -4791,8 +5501,8 @@
         </p:nvSpPr>
         <p:spPr>
           <a:xfrm>
-            <a:off x="5445252" y="2331720"/>
-            <a:ext cx="1417320" cy="914400"/>
+            <a:off x="5445252" y="2057400"/>
+            <a:ext cx="1417320" cy="777240"/>
           </a:xfrm>
           <a:prstGeom prst="rect">
             <a:avLst/>
@@ -4830,7 +5540,7 @@
         </p:nvSpPr>
         <p:spPr>
           <a:xfrm>
-            <a:off x="6862572" y="2788920"/>
+            <a:off x="6862572" y="2446020"/>
             <a:ext cx="164592" cy="0"/>
           </a:xfrm>
           <a:prstGeom prst="line">
@@ -4854,8 +5564,8 @@
         </p:nvSpPr>
         <p:spPr>
           <a:xfrm>
-            <a:off x="7027164" y="2331720"/>
-            <a:ext cx="1417320" cy="914400"/>
+            <a:off x="7027164" y="2057400"/>
+            <a:ext cx="1417320" cy="777240"/>
           </a:xfrm>
           <a:prstGeom prst="rect">
             <a:avLst/>
@@ -4879,8 +5589,8 @@
         </p:nvSpPr>
         <p:spPr>
           <a:xfrm>
-            <a:off x="7027164" y="2331720"/>
-            <a:ext cx="1417320" cy="914400"/>
+            <a:off x="7027164" y="2057400"/>
+            <a:ext cx="1417320" cy="777240"/>
           </a:xfrm>
           <a:prstGeom prst="rect">
             <a:avLst/>
@@ -4904,7 +5614,7 @@
                 <a:ea typeface="Consolas" pitchFamily="34" charset="-122"/>
                 <a:cs typeface="Consolas" pitchFamily="34" charset="-120"/>
               </a:rPr>
-              <a:t>MySQL /</a:t>
+              <a:t>Base de</a:t>
             </a:r>
             <a:endParaRPr lang="en-US" sz="1100" dirty="0"/>
           </a:p>
@@ -4921,7 +5631,7 @@
                 <a:ea typeface="Consolas" pitchFamily="34" charset="-122"/>
                 <a:cs typeface="Consolas" pitchFamily="34" charset="-120"/>
               </a:rPr>
-              <a:t>TiDB Cloud</a:t>
+              <a:t>datos</a:t>
             </a:r>
             <a:endParaRPr lang="en-US" sz="1100" dirty="0"/>
           </a:p>
@@ -4935,8 +5645,8 @@
         </p:nvSpPr>
         <p:spPr>
           <a:xfrm>
-            <a:off x="3863340" y="3886200"/>
-            <a:ext cx="1417320" cy="640080"/>
+            <a:off x="2560320" y="3337560"/>
+            <a:ext cx="4023360" cy="502920"/>
           </a:xfrm>
           <a:prstGeom prst="rect">
             <a:avLst/>
@@ -4960,8 +5670,8 @@
         </p:nvSpPr>
         <p:spPr>
           <a:xfrm>
-            <a:off x="3863340" y="3886200"/>
-            <a:ext cx="1417320" cy="640080"/>
+            <a:off x="2560320" y="3337560"/>
+            <a:ext cx="4023360" cy="502920"/>
           </a:xfrm>
           <a:prstGeom prst="rect">
             <a:avLst/>
@@ -4985,24 +5695,7 @@
                 <a:ea typeface="Consolas" pitchFamily="34" charset="-122"/>
                 <a:cs typeface="Consolas" pitchFamily="34" charset="-120"/>
               </a:rPr>
-              <a:t>Plantilla</a:t>
-            </a:r>
-            <a:endParaRPr lang="en-US" sz="1100" dirty="0"/>
-          </a:p>
-          <a:p>
-            <a:pPr algn="ctr" indent="0" marL="0">
-              <a:buNone/>
-            </a:pPr>
-            <a:r>
-              <a:rPr lang="en-US" sz="1100" b="1" dirty="0">
-                <a:solidFill>
-                  <a:srgbClr val="93713D"/>
-                </a:solidFill>
-                <a:latin typeface="Consolas" pitchFamily="34" charset="0"/>
-                <a:ea typeface="Consolas" pitchFamily="34" charset="-122"/>
-                <a:cs typeface="Consolas" pitchFamily="34" charset="-120"/>
-              </a:rPr>
-              <a:t>Jinja2</a:t>
+              <a:t>Plantilla Jinja2  ←  Datos de vuelta al navegador</a:t>
             </a:r>
             <a:endParaRPr lang="en-US" sz="1100" dirty="0"/>
           </a:p>
@@ -5016,8 +5709,8 @@
         </p:nvSpPr>
         <p:spPr>
           <a:xfrm>
-            <a:off x="4572000" y="3246120"/>
-            <a:ext cx="0" cy="640080"/>
+            <a:off x="4572000" y="2834640"/>
+            <a:ext cx="0" cy="502920"/>
           </a:xfrm>
           <a:prstGeom prst="line">
             <a:avLst/>
@@ -5039,7 +5732,7 @@
         </p:nvSpPr>
         <p:spPr>
           <a:xfrm>
-            <a:off x="4572000" y="3886200"/>
+            <a:off x="4572000" y="3337560"/>
             <a:ext cx="0" cy="0"/>
           </a:xfrm>
           <a:prstGeom prst="line">
@@ -5056,38 +5749,14 @@
       </p:sp>
       <p:sp>
         <p:nvSpPr>
-          <p:cNvPr id="26" name="Shape 24"/>
-          <p:cNvSpPr/>
-          <p:nvPr/>
-        </p:nvSpPr>
-        <p:spPr>
-          <a:xfrm>
-            <a:off x="1408176" y="3246120"/>
-            <a:ext cx="0" cy="640080"/>
-          </a:xfrm>
-          <a:prstGeom prst="line">
-            <a:avLst/>
-          </a:prstGeom>
-          <a:noFill/>
-          <a:ln w="19050">
-            <a:solidFill>
-              <a:srgbClr val="93713D"/>
-            </a:solidFill>
-            <a:prstDash val="dash"/>
-            <a:tailEnd type="triangle"/>
-          </a:ln>
-        </p:spPr>
-      </p:sp>
-      <p:sp>
-        <p:nvSpPr>
-          <p:cNvPr id="27" name="Text 25"/>
-          <p:cNvSpPr/>
-          <p:nvPr/>
-        </p:nvSpPr>
-        <p:spPr>
-          <a:xfrm>
-            <a:off x="640080" y="4663440"/>
-            <a:ext cx="7863840" cy="320040"/>
+          <p:cNvPr id="26" name="Text 24"/>
+          <p:cNvSpPr/>
+          <p:nvPr/>
+        </p:nvSpPr>
+        <p:spPr>
+          <a:xfrm>
+            <a:off x="640080" y="4023360"/>
+            <a:ext cx="7863840" cy="411480"/>
           </a:xfrm>
           <a:prstGeom prst="rect">
             <a:avLst/>
@@ -5096,14 +5765,14 @@
           <a:ln/>
         </p:spPr>
         <p:txBody>
-          <a:bodyPr wrap="square" rtlCol="0" anchor="ctr"/>
+          <a:bodyPr wrap="square" rtlCol="0" anchor="t"/>
           <a:lstStyle/>
           <a:p>
             <a:pPr algn="ctr" indent="0" marL="0">
               <a:buNone/>
             </a:pPr>
             <a:r>
-              <a:rPr lang="en-US" sz="1100" i="1" dirty="0">
+              <a:rPr lang="en-US" sz="1300" i="1" dirty="0">
                 <a:solidFill>
                   <a:srgbClr val="47563F"/>
                 </a:solidFill>
@@ -5111,970 +5780,9 @@
                 <a:ea typeface="Calibri" pitchFamily="34" charset="-122"/>
                 <a:cs typeface="Calibri" pitchFamily="34" charset="-120"/>
               </a:rPr>
-              <a:t>El navegador recibe el HTML renderizado por la plantilla Jinja2</a:t>
-            </a:r>
-            <a:endParaRPr lang="en-US" sz="1100" dirty="0"/>
-          </a:p>
-        </p:txBody>
-      </p:sp>
-    </p:spTree>
-  </p:cSld>
-  <p:clrMapOvr>
-    <a:masterClrMapping/>
-  </p:clrMapOvr>
-</p:sld>
-</file>
-
-<file path=ppt/slides/slide6.xml><?xml version="1.0" encoding="utf-8"?>
-<p:sld xmlns:a="http://schemas.openxmlformats.org/drawingml/2006/main" xmlns:r="http://schemas.openxmlformats.org/officeDocument/2006/relationships" xmlns:p="http://schemas.openxmlformats.org/presentationml/2006/main">
-  <p:cSld name="Slide 6">
-    <p:bg>
-      <p:bgPr>
-        <a:solidFill>
-          <a:srgbClr val="E7EEE3"/>
-        </a:solidFill>
-      </p:bgPr>
-    </p:bg>
-    <p:spTree>
-      <p:nvGrpSpPr>
-        <p:cNvPr id="1" name=""/>
-        <p:cNvGrpSpPr/>
-        <p:nvPr/>
-      </p:nvGrpSpPr>
-      <p:grpSpPr>
-        <a:xfrm>
-          <a:off x="0" y="0"/>
-          <a:ext cx="0" cy="0"/>
-          <a:chOff x="0" y="0"/>
-          <a:chExt cx="0" cy="0"/>
-        </a:xfrm>
-      </p:grpSpPr>
-      <p:sp>
-        <p:nvSpPr>
-          <p:cNvPr id="2" name="Shape 0"/>
-          <p:cNvSpPr/>
-          <p:nvPr/>
-        </p:nvSpPr>
-        <p:spPr>
-          <a:xfrm>
-            <a:off x="109728" y="109728"/>
-            <a:ext cx="8924544" cy="4928616"/>
-          </a:xfrm>
-          <a:prstGeom prst="rect">
-            <a:avLst/>
-          </a:prstGeom>
-          <a:ln w="12700">
-            <a:solidFill>
-              <a:srgbClr val="A8BBA1"/>
-            </a:solidFill>
-            <a:prstDash val="solid"/>
-          </a:ln>
-        </p:spPr>
-      </p:sp>
-      <p:sp>
-        <p:nvSpPr>
-          <p:cNvPr id="3" name="Shape 1"/>
-          <p:cNvSpPr/>
-          <p:nvPr/>
-        </p:nvSpPr>
-        <p:spPr>
-          <a:xfrm>
-            <a:off x="109728" y="109728"/>
-            <a:ext cx="512064" cy="310896"/>
-          </a:xfrm>
-          <a:prstGeom prst="rect">
-            <a:avLst/>
-          </a:prstGeom>
-          <a:solidFill>
-            <a:srgbClr val="DCE6D5"/>
-          </a:solidFill>
-          <a:ln w="12700">
-            <a:solidFill>
-              <a:srgbClr val="A8BBA1"/>
-            </a:solidFill>
-            <a:prstDash val="solid"/>
-          </a:ln>
-        </p:spPr>
-      </p:sp>
-      <p:sp>
-        <p:nvSpPr>
-          <p:cNvPr id="4" name="Text 2"/>
-          <p:cNvSpPr/>
-          <p:nvPr/>
-        </p:nvSpPr>
-        <p:spPr>
-          <a:xfrm>
-            <a:off x="109728" y="109728"/>
-            <a:ext cx="512064" cy="310896"/>
-          </a:xfrm>
-          <a:prstGeom prst="rect">
-            <a:avLst/>
-          </a:prstGeom>
-          <a:noFill/>
-          <a:ln/>
-        </p:spPr>
-        <p:txBody>
-          <a:bodyPr wrap="square" rtlCol="0" anchor="ctr"/>
-          <a:lstStyle/>
-          <a:p>
-            <a:pPr algn="ctr" indent="0" marL="0">
-              <a:buNone/>
-            </a:pPr>
-            <a:r>
-              <a:rPr lang="en-US" sz="1100" b="1" dirty="0">
-                <a:solidFill>
-                  <a:srgbClr val="93713D"/>
-                </a:solidFill>
-                <a:latin typeface="Consolas" pitchFamily="34" charset="0"/>
-                <a:ea typeface="Consolas" pitchFamily="34" charset="-122"/>
-                <a:cs typeface="Consolas" pitchFamily="34" charset="-120"/>
-              </a:rPr>
-              <a:t>06</a:t>
-            </a:r>
-            <a:endParaRPr lang="en-US" sz="1100" dirty="0"/>
-          </a:p>
-        </p:txBody>
-      </p:sp>
-      <p:sp>
-        <p:nvSpPr>
-          <p:cNvPr id="5" name="Text 3"/>
-          <p:cNvSpPr/>
-          <p:nvPr/>
-        </p:nvSpPr>
-        <p:spPr>
-          <a:xfrm>
-            <a:off x="640080" y="502920"/>
-            <a:ext cx="7863840" cy="274320"/>
-          </a:xfrm>
-          <a:prstGeom prst="rect">
-            <a:avLst/>
-          </a:prstGeom>
-          <a:noFill/>
-          <a:ln/>
-        </p:spPr>
-        <p:txBody>
-          <a:bodyPr wrap="square" rtlCol="0" anchor="ctr"/>
-          <a:lstStyle/>
-          <a:p>
-            <a:pPr indent="0" marL="0">
-              <a:buNone/>
-            </a:pPr>
-            <a:r>
-              <a:rPr lang="en-US" sz="1100" b="1" spc="200" kern="0" dirty="0">
-                <a:solidFill>
-                  <a:srgbClr val="93713D"/>
-                </a:solidFill>
-                <a:latin typeface="Consolas" pitchFamily="34" charset="0"/>
-                <a:ea typeface="Consolas" pitchFamily="34" charset="-122"/>
-                <a:cs typeface="Consolas" pitchFamily="34" charset="-120"/>
-              </a:rPr>
-              <a:t>COMISIONES · EL CAMBIO DE HOY</a:t>
-            </a:r>
-            <a:endParaRPr lang="en-US" sz="1100" dirty="0"/>
-          </a:p>
-        </p:txBody>
-      </p:sp>
-      <p:sp>
-        <p:nvSpPr>
-          <p:cNvPr id="6" name="Text 4"/>
-          <p:cNvSpPr/>
-          <p:nvPr/>
-        </p:nvSpPr>
-        <p:spPr>
-          <a:xfrm>
-            <a:off x="640080" y="868680"/>
-            <a:ext cx="7863840" cy="548640"/>
-          </a:xfrm>
-          <a:prstGeom prst="rect">
-            <a:avLst/>
-          </a:prstGeom>
-          <a:noFill/>
-          <a:ln/>
-        </p:spPr>
-        <p:txBody>
-          <a:bodyPr wrap="square" rtlCol="0" anchor="t"/>
-          <a:lstStyle/>
-          <a:p>
-            <a:pPr indent="0" marL="0">
-              <a:buNone/>
-            </a:pPr>
-            <a:r>
-              <a:rPr lang="en-US" sz="2600" b="1" dirty="0">
-                <a:solidFill>
-                  <a:srgbClr val="16241B"/>
-                </a:solidFill>
-                <a:latin typeface="Georgia" pitchFamily="34" charset="0"/>
-                <a:ea typeface="Georgia" pitchFamily="34" charset="-122"/>
-                <a:cs typeface="Georgia" pitchFamily="34" charset="-120"/>
-              </a:rPr>
-              <a:t>El flujo de comisiones se simplificó</a:t>
-            </a:r>
-            <a:endParaRPr lang="en-US" sz="2600" dirty="0"/>
-          </a:p>
-        </p:txBody>
-      </p:sp>
-      <p:sp>
-        <p:nvSpPr>
-          <p:cNvPr id="7" name="Shape 5"/>
-          <p:cNvSpPr/>
-          <p:nvPr/>
-        </p:nvSpPr>
-        <p:spPr>
-          <a:xfrm>
-            <a:off x="640080" y="1600200"/>
-            <a:ext cx="3749040" cy="3200400"/>
-          </a:xfrm>
-          <a:prstGeom prst="rect">
-            <a:avLst/>
-          </a:prstGeom>
-          <a:solidFill>
-            <a:srgbClr val="DCE6D5"/>
-          </a:solidFill>
-          <a:ln w="12700">
-            <a:solidFill>
-              <a:srgbClr val="A8BBA1"/>
-            </a:solidFill>
-            <a:prstDash val="solid"/>
-          </a:ln>
-        </p:spPr>
-      </p:sp>
-      <p:sp>
-        <p:nvSpPr>
-          <p:cNvPr id="8" name="Text 6"/>
-          <p:cNvSpPr/>
-          <p:nvPr/>
-        </p:nvSpPr>
-        <p:spPr>
-          <a:xfrm>
-            <a:off x="868680" y="1764792"/>
-            <a:ext cx="3291840" cy="320040"/>
-          </a:xfrm>
-          <a:prstGeom prst="rect">
-            <a:avLst/>
-          </a:prstGeom>
-          <a:noFill/>
-          <a:ln/>
-        </p:spPr>
-        <p:txBody>
-          <a:bodyPr wrap="square" rtlCol="0" anchor="ctr"/>
-          <a:lstStyle/>
-          <a:p>
-            <a:pPr indent="0" marL="0">
-              <a:buNone/>
-            </a:pPr>
-            <a:r>
-              <a:rPr lang="en-US" sz="1300" b="1" dirty="0">
-                <a:solidFill>
-                  <a:srgbClr val="93713D"/>
-                </a:solidFill>
-                <a:latin typeface="Consolas" pitchFamily="34" charset="0"/>
-                <a:ea typeface="Consolas" pitchFamily="34" charset="-122"/>
-                <a:cs typeface="Consolas" pitchFamily="34" charset="-120"/>
-              </a:rPr>
-              <a:t>ANTES</a:t>
+              <a:t>Sin capas innecesarias: menos piezas moviéndose, menos lugares donde algo puede fallar.</a:t>
             </a:r>
             <a:endParaRPr lang="en-US" sz="1300" dirty="0"/>
-          </a:p>
-        </p:txBody>
-      </p:sp>
-      <p:sp>
-        <p:nvSpPr>
-          <p:cNvPr id="9" name="Text 7"/>
-          <p:cNvSpPr/>
-          <p:nvPr/>
-        </p:nvSpPr>
-        <p:spPr>
-          <a:xfrm>
-            <a:off x="868680" y="2103120"/>
-            <a:ext cx="3291840" cy="365760"/>
-          </a:xfrm>
-          <a:prstGeom prst="rect">
-            <a:avLst/>
-          </a:prstGeom>
-          <a:noFill/>
-          <a:ln/>
-        </p:spPr>
-        <p:txBody>
-          <a:bodyPr wrap="square" rtlCol="0" anchor="ctr"/>
-          <a:lstStyle/>
-          <a:p>
-            <a:pPr indent="0" marL="0">
-              <a:buNone/>
-            </a:pPr>
-            <a:r>
-              <a:rPr lang="en-US" sz="1200" i="1" dirty="0">
-                <a:solidFill>
-                  <a:srgbClr val="47563F"/>
-                </a:solidFill>
-                <a:latin typeface="Calibri" pitchFamily="34" charset="0"/>
-                <a:ea typeface="Calibri" pitchFamily="34" charset="-122"/>
-                <a:cs typeface="Calibri" pitchFamily="34" charset="-120"/>
-              </a:rPr>
-              <a:t>9 tarjetas de carga, una por aseguradora</a:t>
-            </a:r>
-            <a:endParaRPr lang="en-US" sz="1200" dirty="0"/>
-          </a:p>
-        </p:txBody>
-      </p:sp>
-      <p:sp>
-        <p:nvSpPr>
-          <p:cNvPr id="10" name="Text 8"/>
-          <p:cNvSpPr/>
-          <p:nvPr/>
-        </p:nvSpPr>
-        <p:spPr>
-          <a:xfrm>
-            <a:off x="960120" y="2560320"/>
-            <a:ext cx="3108960" cy="237744"/>
-          </a:xfrm>
-          <a:prstGeom prst="rect">
-            <a:avLst/>
-          </a:prstGeom>
-          <a:noFill/>
-          <a:ln/>
-        </p:spPr>
-        <p:txBody>
-          <a:bodyPr wrap="square" rtlCol="0" anchor="ctr"/>
-          <a:lstStyle/>
-          <a:p>
-            <a:pPr indent="0" marL="0">
-              <a:buNone/>
-            </a:pPr>
-            <a:r>
-              <a:rPr lang="en-US" sz="1100" dirty="0">
-                <a:solidFill>
-                  <a:srgbClr val="16241B"/>
-                </a:solidFill>
-                <a:latin typeface="Consolas" pitchFamily="34" charset="0"/>
-                <a:ea typeface="Consolas" pitchFamily="34" charset="-122"/>
-                <a:cs typeface="Consolas" pitchFamily="34" charset="-120"/>
-              </a:rPr>
-              <a:t>· Star</a:t>
-            </a:r>
-            <a:endParaRPr lang="en-US" sz="1100" dirty="0"/>
-          </a:p>
-        </p:txBody>
-      </p:sp>
-      <p:sp>
-        <p:nvSpPr>
-          <p:cNvPr id="11" name="Text 9"/>
-          <p:cNvSpPr/>
-          <p:nvPr/>
-        </p:nvSpPr>
-        <p:spPr>
-          <a:xfrm>
-            <a:off x="960120" y="2807208"/>
-            <a:ext cx="3108960" cy="237744"/>
-          </a:xfrm>
-          <a:prstGeom prst="rect">
-            <a:avLst/>
-          </a:prstGeom>
-          <a:noFill/>
-          <a:ln/>
-        </p:spPr>
-        <p:txBody>
-          <a:bodyPr wrap="square" rtlCol="0" anchor="ctr"/>
-          <a:lstStyle/>
-          <a:p>
-            <a:pPr indent="0" marL="0">
-              <a:buNone/>
-            </a:pPr>
-            <a:r>
-              <a:rPr lang="en-US" sz="1100" dirty="0">
-                <a:solidFill>
-                  <a:srgbClr val="16241B"/>
-                </a:solidFill>
-                <a:latin typeface="Consolas" pitchFamily="34" charset="0"/>
-                <a:ea typeface="Consolas" pitchFamily="34" charset="-122"/>
-                <a:cs typeface="Consolas" pitchFamily="34" charset="-120"/>
-              </a:rPr>
-              <a:t>· Caracas</a:t>
-            </a:r>
-            <a:endParaRPr lang="en-US" sz="1100" dirty="0"/>
-          </a:p>
-        </p:txBody>
-      </p:sp>
-      <p:sp>
-        <p:nvSpPr>
-          <p:cNvPr id="12" name="Text 10"/>
-          <p:cNvSpPr/>
-          <p:nvPr/>
-        </p:nvSpPr>
-        <p:spPr>
-          <a:xfrm>
-            <a:off x="960120" y="3054096"/>
-            <a:ext cx="3108960" cy="237744"/>
-          </a:xfrm>
-          <a:prstGeom prst="rect">
-            <a:avLst/>
-          </a:prstGeom>
-          <a:noFill/>
-          <a:ln/>
-        </p:spPr>
-        <p:txBody>
-          <a:bodyPr wrap="square" rtlCol="0" anchor="ctr"/>
-          <a:lstStyle/>
-          <a:p>
-            <a:pPr indent="0" marL="0">
-              <a:buNone/>
-            </a:pPr>
-            <a:r>
-              <a:rPr lang="en-US" sz="1100" dirty="0">
-                <a:solidFill>
-                  <a:srgbClr val="16241B"/>
-                </a:solidFill>
-                <a:latin typeface="Consolas" pitchFamily="34" charset="0"/>
-                <a:ea typeface="Consolas" pitchFamily="34" charset="-122"/>
-                <a:cs typeface="Consolas" pitchFamily="34" charset="-120"/>
-              </a:rPr>
-              <a:t>· Mercantil</a:t>
-            </a:r>
-            <a:endParaRPr lang="en-US" sz="1100" dirty="0"/>
-          </a:p>
-        </p:txBody>
-      </p:sp>
-      <p:sp>
-        <p:nvSpPr>
-          <p:cNvPr id="13" name="Text 11"/>
-          <p:cNvSpPr/>
-          <p:nvPr/>
-        </p:nvSpPr>
-        <p:spPr>
-          <a:xfrm>
-            <a:off x="960120" y="3300984"/>
-            <a:ext cx="3108960" cy="237744"/>
-          </a:xfrm>
-          <a:prstGeom prst="rect">
-            <a:avLst/>
-          </a:prstGeom>
-          <a:noFill/>
-          <a:ln/>
-        </p:spPr>
-        <p:txBody>
-          <a:bodyPr wrap="square" rtlCol="0" anchor="ctr"/>
-          <a:lstStyle/>
-          <a:p>
-            <a:pPr indent="0" marL="0">
-              <a:buNone/>
-            </a:pPr>
-            <a:r>
-              <a:rPr lang="en-US" sz="1100" dirty="0">
-                <a:solidFill>
-                  <a:srgbClr val="16241B"/>
-                </a:solidFill>
-                <a:latin typeface="Consolas" pitchFamily="34" charset="0"/>
-                <a:ea typeface="Consolas" pitchFamily="34" charset="-122"/>
-                <a:cs typeface="Consolas" pitchFamily="34" charset="-120"/>
-              </a:rPr>
-              <a:t>· Internacional</a:t>
-            </a:r>
-            <a:endParaRPr lang="en-US" sz="1100" dirty="0"/>
-          </a:p>
-        </p:txBody>
-      </p:sp>
-      <p:sp>
-        <p:nvSpPr>
-          <p:cNvPr id="14" name="Text 12"/>
-          <p:cNvSpPr/>
-          <p:nvPr/>
-        </p:nvSpPr>
-        <p:spPr>
-          <a:xfrm>
-            <a:off x="960120" y="3547872"/>
-            <a:ext cx="3108960" cy="237744"/>
-          </a:xfrm>
-          <a:prstGeom prst="rect">
-            <a:avLst/>
-          </a:prstGeom>
-          <a:noFill/>
-          <a:ln/>
-        </p:spPr>
-        <p:txBody>
-          <a:bodyPr wrap="square" rtlCol="0" anchor="ctr"/>
-          <a:lstStyle/>
-          <a:p>
-            <a:pPr indent="0" marL="0">
-              <a:buNone/>
-            </a:pPr>
-            <a:r>
-              <a:rPr lang="en-US" sz="1100" dirty="0">
-                <a:solidFill>
-                  <a:srgbClr val="16241B"/>
-                </a:solidFill>
-                <a:latin typeface="Consolas" pitchFamily="34" charset="0"/>
-                <a:ea typeface="Consolas" pitchFamily="34" charset="-122"/>
-                <a:cs typeface="Consolas" pitchFamily="34" charset="-120"/>
-              </a:rPr>
-              <a:t>· Oceánica</a:t>
-            </a:r>
-            <a:endParaRPr lang="en-US" sz="1100" dirty="0"/>
-          </a:p>
-        </p:txBody>
-      </p:sp>
-      <p:sp>
-        <p:nvSpPr>
-          <p:cNvPr id="15" name="Text 13"/>
-          <p:cNvSpPr/>
-          <p:nvPr/>
-        </p:nvSpPr>
-        <p:spPr>
-          <a:xfrm>
-            <a:off x="960120" y="3794760"/>
-            <a:ext cx="3108960" cy="237744"/>
-          </a:xfrm>
-          <a:prstGeom prst="rect">
-            <a:avLst/>
-          </a:prstGeom>
-          <a:noFill/>
-          <a:ln/>
-        </p:spPr>
-        <p:txBody>
-          <a:bodyPr wrap="square" rtlCol="0" anchor="ctr"/>
-          <a:lstStyle/>
-          <a:p>
-            <a:pPr indent="0" marL="0">
-              <a:buNone/>
-            </a:pPr>
-            <a:r>
-              <a:rPr lang="en-US" sz="1100" dirty="0">
-                <a:solidFill>
-                  <a:srgbClr val="16241B"/>
-                </a:solidFill>
-                <a:latin typeface="Consolas" pitchFamily="34" charset="0"/>
-                <a:ea typeface="Consolas" pitchFamily="34" charset="-122"/>
-                <a:cs typeface="Consolas" pitchFamily="34" charset="-120"/>
-              </a:rPr>
-              <a:t>· Pirámide</a:t>
-            </a:r>
-            <a:endParaRPr lang="en-US" sz="1100" dirty="0"/>
-          </a:p>
-        </p:txBody>
-      </p:sp>
-      <p:sp>
-        <p:nvSpPr>
-          <p:cNvPr id="16" name="Text 14"/>
-          <p:cNvSpPr/>
-          <p:nvPr/>
-        </p:nvSpPr>
-        <p:spPr>
-          <a:xfrm>
-            <a:off x="960120" y="4041648"/>
-            <a:ext cx="3108960" cy="237744"/>
-          </a:xfrm>
-          <a:prstGeom prst="rect">
-            <a:avLst/>
-          </a:prstGeom>
-          <a:noFill/>
-          <a:ln/>
-        </p:spPr>
-        <p:txBody>
-          <a:bodyPr wrap="square" rtlCol="0" anchor="ctr"/>
-          <a:lstStyle/>
-          <a:p>
-            <a:pPr indent="0" marL="0">
-              <a:buNone/>
-            </a:pPr>
-            <a:r>
-              <a:rPr lang="en-US" sz="1100" dirty="0">
-                <a:solidFill>
-                  <a:srgbClr val="16241B"/>
-                </a:solidFill>
-                <a:latin typeface="Consolas" pitchFamily="34" charset="0"/>
-                <a:ea typeface="Consolas" pitchFamily="34" charset="-122"/>
-                <a:cs typeface="Consolas" pitchFamily="34" charset="-120"/>
-              </a:rPr>
-              <a:t>· Venezuela</a:t>
-            </a:r>
-            <a:endParaRPr lang="en-US" sz="1100" dirty="0"/>
-          </a:p>
-        </p:txBody>
-      </p:sp>
-      <p:sp>
-        <p:nvSpPr>
-          <p:cNvPr id="17" name="Text 15"/>
-          <p:cNvSpPr/>
-          <p:nvPr/>
-        </p:nvSpPr>
-        <p:spPr>
-          <a:xfrm>
-            <a:off x="960120" y="4288536"/>
-            <a:ext cx="3108960" cy="237744"/>
-          </a:xfrm>
-          <a:prstGeom prst="rect">
-            <a:avLst/>
-          </a:prstGeom>
-          <a:noFill/>
-          <a:ln/>
-        </p:spPr>
-        <p:txBody>
-          <a:bodyPr wrap="square" rtlCol="0" anchor="ctr"/>
-          <a:lstStyle/>
-          <a:p>
-            <a:pPr indent="0" marL="0">
-              <a:buNone/>
-            </a:pPr>
-            <a:r>
-              <a:rPr lang="en-US" sz="1100" dirty="0">
-                <a:solidFill>
-                  <a:srgbClr val="16241B"/>
-                </a:solidFill>
-                <a:latin typeface="Consolas" pitchFamily="34" charset="0"/>
-                <a:ea typeface="Consolas" pitchFamily="34" charset="-122"/>
-                <a:cs typeface="Consolas" pitchFamily="34" charset="-120"/>
-              </a:rPr>
-              <a:t>· Universitas</a:t>
-            </a:r>
-            <a:endParaRPr lang="en-US" sz="1100" dirty="0"/>
-          </a:p>
-        </p:txBody>
-      </p:sp>
-      <p:sp>
-        <p:nvSpPr>
-          <p:cNvPr id="18" name="Text 16"/>
-          <p:cNvSpPr/>
-          <p:nvPr/>
-        </p:nvSpPr>
-        <p:spPr>
-          <a:xfrm>
-            <a:off x="960120" y="4535424"/>
-            <a:ext cx="3108960" cy="237744"/>
-          </a:xfrm>
-          <a:prstGeom prst="rect">
-            <a:avLst/>
-          </a:prstGeom>
-          <a:noFill/>
-          <a:ln/>
-        </p:spPr>
-        <p:txBody>
-          <a:bodyPr wrap="square" rtlCol="0" anchor="ctr"/>
-          <a:lstStyle/>
-          <a:p>
-            <a:pPr indent="0" marL="0">
-              <a:buNone/>
-            </a:pPr>
-            <a:r>
-              <a:rPr lang="en-US" sz="1100" dirty="0">
-                <a:solidFill>
-                  <a:srgbClr val="16241B"/>
-                </a:solidFill>
-                <a:latin typeface="Consolas" pitchFamily="34" charset="0"/>
-                <a:ea typeface="Consolas" pitchFamily="34" charset="-122"/>
-                <a:cs typeface="Consolas" pitchFamily="34" charset="-120"/>
-              </a:rPr>
-              <a:t>· Banesco</a:t>
-            </a:r>
-            <a:endParaRPr lang="en-US" sz="1100" dirty="0"/>
-          </a:p>
-        </p:txBody>
-      </p:sp>
-      <p:sp>
-        <p:nvSpPr>
-          <p:cNvPr id="19" name="Shape 17"/>
-          <p:cNvSpPr/>
-          <p:nvPr/>
-        </p:nvSpPr>
-        <p:spPr>
-          <a:xfrm>
-            <a:off x="4754880" y="1600200"/>
-            <a:ext cx="3749040" cy="3200400"/>
-          </a:xfrm>
-          <a:prstGeom prst="rect">
-            <a:avLst/>
-          </a:prstGeom>
-          <a:solidFill>
-            <a:srgbClr val="E7EEE3"/>
-          </a:solidFill>
-          <a:ln w="19050">
-            <a:solidFill>
-              <a:srgbClr val="1A56DB"/>
-            </a:solidFill>
-            <a:prstDash val="solid"/>
-          </a:ln>
-        </p:spPr>
-      </p:sp>
-      <p:sp>
-        <p:nvSpPr>
-          <p:cNvPr id="20" name="Text 18"/>
-          <p:cNvSpPr/>
-          <p:nvPr/>
-        </p:nvSpPr>
-        <p:spPr>
-          <a:xfrm>
-            <a:off x="4983480" y="1764792"/>
-            <a:ext cx="3291840" cy="320040"/>
-          </a:xfrm>
-          <a:prstGeom prst="rect">
-            <a:avLst/>
-          </a:prstGeom>
-          <a:noFill/>
-          <a:ln/>
-        </p:spPr>
-        <p:txBody>
-          <a:bodyPr wrap="square" rtlCol="0" anchor="ctr"/>
-          <a:lstStyle/>
-          <a:p>
-            <a:pPr indent="0" marL="0">
-              <a:buNone/>
-            </a:pPr>
-            <a:r>
-              <a:rPr lang="en-US" sz="1300" b="1" dirty="0">
-                <a:solidFill>
-                  <a:srgbClr val="1A56DB"/>
-                </a:solidFill>
-                <a:latin typeface="Consolas" pitchFamily="34" charset="0"/>
-                <a:ea typeface="Consolas" pitchFamily="34" charset="-122"/>
-                <a:cs typeface="Consolas" pitchFamily="34" charset="-120"/>
-              </a:rPr>
-              <a:t>AHORA</a:t>
-            </a:r>
-            <a:endParaRPr lang="en-US" sz="1300" dirty="0"/>
-          </a:p>
-        </p:txBody>
-      </p:sp>
-      <p:sp>
-        <p:nvSpPr>
-          <p:cNvPr id="21" name="Text 19"/>
-          <p:cNvSpPr/>
-          <p:nvPr/>
-        </p:nvSpPr>
-        <p:spPr>
-          <a:xfrm>
-            <a:off x="4983480" y="2103120"/>
-            <a:ext cx="3291840" cy="365760"/>
-          </a:xfrm>
-          <a:prstGeom prst="rect">
-            <a:avLst/>
-          </a:prstGeom>
-          <a:noFill/>
-          <a:ln/>
-        </p:spPr>
-        <p:txBody>
-          <a:bodyPr wrap="square" rtlCol="0" anchor="ctr"/>
-          <a:lstStyle/>
-          <a:p>
-            <a:pPr indent="0" marL="0">
-              <a:buNone/>
-            </a:pPr>
-            <a:r>
-              <a:rPr lang="en-US" sz="1200" i="1" dirty="0">
-                <a:solidFill>
-                  <a:srgbClr val="47563F"/>
-                </a:solidFill>
-                <a:latin typeface="Calibri" pitchFamily="34" charset="0"/>
-                <a:ea typeface="Calibri" pitchFamily="34" charset="-122"/>
-                <a:cs typeface="Calibri" pitchFamily="34" charset="-120"/>
-              </a:rPr>
-              <a:t>Un único formulario para todas las aseguradoras</a:t>
-            </a:r>
-            <a:endParaRPr lang="en-US" sz="1200" dirty="0"/>
-          </a:p>
-        </p:txBody>
-      </p:sp>
-      <p:sp>
-        <p:nvSpPr>
-          <p:cNvPr id="22" name="Shape 20"/>
-          <p:cNvSpPr/>
-          <p:nvPr/>
-        </p:nvSpPr>
-        <p:spPr>
-          <a:xfrm>
-            <a:off x="4983480" y="2651760"/>
-            <a:ext cx="3291840" cy="640080"/>
-          </a:xfrm>
-          <a:prstGeom prst="rect">
-            <a:avLst/>
-          </a:prstGeom>
-          <a:solidFill>
-            <a:srgbClr val="DCE6D5"/>
-          </a:solidFill>
-          <a:ln w="12700">
-            <a:solidFill>
-              <a:srgbClr val="A8BBA1"/>
-            </a:solidFill>
-            <a:prstDash val="solid"/>
-          </a:ln>
-        </p:spPr>
-      </p:sp>
-      <p:sp>
-        <p:nvSpPr>
-          <p:cNvPr id="23" name="Text 21"/>
-          <p:cNvSpPr/>
-          <p:nvPr/>
-        </p:nvSpPr>
-        <p:spPr>
-          <a:xfrm>
-            <a:off x="4983480" y="2651760"/>
-            <a:ext cx="3291840" cy="640080"/>
-          </a:xfrm>
-          <a:prstGeom prst="rect">
-            <a:avLst/>
-          </a:prstGeom>
-          <a:noFill/>
-          <a:ln/>
-        </p:spPr>
-        <p:txBody>
-          <a:bodyPr wrap="square" rtlCol="0" anchor="ctr"/>
-          <a:lstStyle/>
-          <a:p>
-            <a:pPr algn="ctr" indent="0" marL="0">
-              <a:buNone/>
-            </a:pPr>
-            <a:r>
-              <a:rPr lang="en-US" sz="1200" b="1" dirty="0">
-                <a:solidFill>
-                  <a:srgbClr val="16241B"/>
-                </a:solidFill>
-                <a:latin typeface="Consolas" pitchFamily="34" charset="0"/>
-                <a:ea typeface="Consolas" pitchFamily="34" charset="-122"/>
-                <a:cs typeface="Consolas" pitchFamily="34" charset="-120"/>
-              </a:rPr>
-              <a:t>Registro de Comisión</a:t>
-            </a:r>
-            <a:endParaRPr lang="en-US" sz="1200" dirty="0"/>
-          </a:p>
-          <a:p>
-            <a:pPr algn="ctr" indent="0" marL="0">
-              <a:buNone/>
-            </a:pPr>
-            <a:r>
-              <a:rPr lang="en-US" sz="1200" b="1" dirty="0">
-                <a:solidFill>
-                  <a:srgbClr val="16241B"/>
-                </a:solidFill>
-                <a:latin typeface="Consolas" pitchFamily="34" charset="0"/>
-                <a:ea typeface="Consolas" pitchFamily="34" charset="-122"/>
-                <a:cs typeface="Consolas" pitchFamily="34" charset="-120"/>
-              </a:rPr>
-              <a:t>Recibida</a:t>
-            </a:r>
-            <a:endParaRPr lang="en-US" sz="1200" dirty="0"/>
-          </a:p>
-        </p:txBody>
-      </p:sp>
-      <p:sp>
-        <p:nvSpPr>
-          <p:cNvPr id="24" name="Shape 22"/>
-          <p:cNvSpPr/>
-          <p:nvPr/>
-        </p:nvSpPr>
-        <p:spPr>
-          <a:xfrm>
-            <a:off x="6629400" y="3291840"/>
-            <a:ext cx="0" cy="274320"/>
-          </a:xfrm>
-          <a:prstGeom prst="line">
-            <a:avLst/>
-          </a:prstGeom>
-          <a:noFill/>
-          <a:ln w="25400">
-            <a:solidFill>
-              <a:srgbClr val="1A56DB"/>
-            </a:solidFill>
-            <a:prstDash val="solid"/>
-            <a:tailEnd type="triangle"/>
-          </a:ln>
-        </p:spPr>
-      </p:sp>
-      <p:sp>
-        <p:nvSpPr>
-          <p:cNvPr id="25" name="Shape 23"/>
-          <p:cNvSpPr/>
-          <p:nvPr/>
-        </p:nvSpPr>
-        <p:spPr>
-          <a:xfrm>
-            <a:off x="4983480" y="3566160"/>
-            <a:ext cx="3291840" cy="640080"/>
-          </a:xfrm>
-          <a:prstGeom prst="rect">
-            <a:avLst/>
-          </a:prstGeom>
-          <a:solidFill>
-            <a:srgbClr val="DCE6D5"/>
-          </a:solidFill>
-          <a:ln w="12700">
-            <a:solidFill>
-              <a:srgbClr val="A8BBA1"/>
-            </a:solidFill>
-            <a:prstDash val="solid"/>
-          </a:ln>
-        </p:spPr>
-      </p:sp>
-      <p:sp>
-        <p:nvSpPr>
-          <p:cNvPr id="26" name="Text 24"/>
-          <p:cNvSpPr/>
-          <p:nvPr/>
-        </p:nvSpPr>
-        <p:spPr>
-          <a:xfrm>
-            <a:off x="4983480" y="3566160"/>
-            <a:ext cx="3291840" cy="640080"/>
-          </a:xfrm>
-          <a:prstGeom prst="rect">
-            <a:avLst/>
-          </a:prstGeom>
-          <a:noFill/>
-          <a:ln/>
-        </p:spPr>
-        <p:txBody>
-          <a:bodyPr wrap="square" rtlCol="0" anchor="ctr"/>
-          <a:lstStyle/>
-          <a:p>
-            <a:pPr algn="ctr" indent="0" marL="0">
-              <a:buNone/>
-            </a:pPr>
-            <a:r>
-              <a:rPr lang="en-US" sz="1200" b="1" dirty="0">
-                <a:solidFill>
-                  <a:srgbClr val="1A56DB"/>
-                </a:solidFill>
-                <a:latin typeface="Consolas" pitchFamily="34" charset="0"/>
-                <a:ea typeface="Consolas" pitchFamily="34" charset="-122"/>
-                <a:cs typeface="Consolas" pitchFamily="34" charset="-120"/>
-              </a:rPr>
-              <a:t>Carga Manual</a:t>
-            </a:r>
-            <a:endParaRPr lang="en-US" sz="1200" dirty="0"/>
-          </a:p>
-        </p:txBody>
-      </p:sp>
-      <p:sp>
-        <p:nvSpPr>
-          <p:cNvPr id="27" name="Text 25"/>
-          <p:cNvSpPr/>
-          <p:nvPr/>
-        </p:nvSpPr>
-        <p:spPr>
-          <a:xfrm>
-            <a:off x="4983480" y="4297680"/>
-            <a:ext cx="3291840" cy="320040"/>
-          </a:xfrm>
-          <a:prstGeom prst="rect">
-            <a:avLst/>
-          </a:prstGeom>
-          <a:noFill/>
-          <a:ln/>
-        </p:spPr>
-        <p:txBody>
-          <a:bodyPr wrap="square" rtlCol="0" anchor="ctr"/>
-          <a:lstStyle/>
-          <a:p>
-            <a:pPr algn="ctr" indent="0" marL="0">
-              <a:buNone/>
-            </a:pPr>
-            <a:r>
-              <a:rPr lang="en-US" sz="1100" dirty="0">
-                <a:solidFill>
-                  <a:srgbClr val="47563F"/>
-                </a:solidFill>
-                <a:latin typeface="Calibri" pitchFamily="34" charset="0"/>
-                <a:ea typeface="Calibri" pitchFamily="34" charset="-122"/>
-                <a:cs typeface="Calibri" pitchFamily="34" charset="-120"/>
-              </a:rPr>
-              <a:t>Un único formulario</a:t>
-            </a:r>
-            <a:endParaRPr lang="en-US" sz="1100" dirty="0"/>
           </a:p>
         </p:txBody>
       </p:sp>
@@ -6190,7 +5898,7 @@
                 <a:ea typeface="Consolas" pitchFamily="34" charset="-122"/>
                 <a:cs typeface="Consolas" pitchFamily="34" charset="-120"/>
               </a:rPr>
-              <a:t>07</a:t>
+              <a:t>06</a:t>
             </a:r>
             <a:endParaRPr lang="en-US" sz="1100" dirty="0"/>
           </a:p>
@@ -6229,7 +5937,7 @@
                 <a:ea typeface="Consolas" pitchFamily="34" charset="-122"/>
                 <a:cs typeface="Consolas" pitchFamily="34" charset="-120"/>
               </a:rPr>
-              <a:t>DESPLIEGUE</a:t>
+              <a:t>LO QUE YA FUNCIONA</a:t>
             </a:r>
             <a:endParaRPr lang="en-US" sz="1100" dirty="0"/>
           </a:p>
@@ -6244,7 +5952,7 @@
         <p:spPr>
           <a:xfrm>
             <a:off x="640080" y="868680"/>
-            <a:ext cx="7863840" cy="548640"/>
+            <a:ext cx="7863840" cy="640080"/>
           </a:xfrm>
           <a:prstGeom prst="rect">
             <a:avLst/>
@@ -6260,7 +5968,7 @@
               <a:buNone/>
             </a:pPr>
             <a:r>
-              <a:rPr lang="en-US" sz="2600" b="1" dirty="0">
+              <a:rPr lang="en-US" sz="2800" b="1" dirty="0">
                 <a:solidFill>
                   <a:srgbClr val="16241B"/>
                 </a:solidFill>
@@ -6268,9 +5976,9 @@
                 <a:ea typeface="Georgia" pitchFamily="34" charset="-122"/>
                 <a:cs typeface="Georgia" pitchFamily="34" charset="-120"/>
               </a:rPr>
-              <a:t>Dos rutas de despliegue, mismo código</a:t>
+              <a:t>Dónde está el proyecto hoy</a:t>
             </a:r>
-            <a:endParaRPr lang="en-US" sz="2600" dirty="0"/>
+            <a:endParaRPr lang="en-US" sz="2800" dirty="0"/>
           </a:p>
         </p:txBody>
       </p:sp>
@@ -6282,21 +5990,16 @@
         </p:nvSpPr>
         <p:spPr>
           <a:xfrm>
-            <a:off x="640080" y="1691640"/>
-            <a:ext cx="3749040" cy="2926080"/>
+            <a:off x="640080" y="1911096"/>
+            <a:ext cx="128016" cy="128016"/>
           </a:xfrm>
           <a:prstGeom prst="rect">
             <a:avLst/>
           </a:prstGeom>
           <a:solidFill>
-            <a:srgbClr val="DCE6D5"/>
+            <a:srgbClr val="1A56DB"/>
           </a:solidFill>
-          <a:ln w="19050">
-            <a:solidFill>
-              <a:srgbClr val="1A56DB"/>
-            </a:solidFill>
-            <a:prstDash val="solid"/>
-          </a:ln>
+          <a:ln/>
         </p:spPr>
       </p:sp>
       <p:sp>
@@ -6307,86 +6010,8 @@
         </p:nvSpPr>
         <p:spPr>
           <a:xfrm>
-            <a:off x="868680" y="1874520"/>
-            <a:ext cx="3291840" cy="320040"/>
-          </a:xfrm>
-          <a:prstGeom prst="rect">
-            <a:avLst/>
-          </a:prstGeom>
-          <a:noFill/>
-          <a:ln/>
-        </p:spPr>
-        <p:txBody>
-          <a:bodyPr wrap="square" rtlCol="0" anchor="ctr"/>
-          <a:lstStyle/>
-          <a:p>
-            <a:pPr indent="0" marL="0">
-              <a:buNone/>
-            </a:pPr>
-            <a:r>
-              <a:rPr lang="en-US" sz="1300" b="1" dirty="0">
-                <a:solidFill>
-                  <a:srgbClr val="1A56DB"/>
-                </a:solidFill>
-                <a:latin typeface="Consolas" pitchFamily="34" charset="0"/>
-                <a:ea typeface="Consolas" pitchFamily="34" charset="-122"/>
-                <a:cs typeface="Consolas" pitchFamily="34" charset="-120"/>
-              </a:rPr>
-              <a:t>RENDER.COM</a:t>
-            </a:r>
-            <a:endParaRPr lang="en-US" sz="1300" dirty="0"/>
-          </a:p>
-        </p:txBody>
-      </p:sp>
-      <p:sp>
-        <p:nvSpPr>
-          <p:cNvPr id="9" name="Text 7"/>
-          <p:cNvSpPr/>
-          <p:nvPr/>
-        </p:nvSpPr>
-        <p:spPr>
-          <a:xfrm>
-            <a:off x="868680" y="2221992"/>
-            <a:ext cx="3291840" cy="274320"/>
-          </a:xfrm>
-          <a:prstGeom prst="rect">
-            <a:avLst/>
-          </a:prstGeom>
-          <a:noFill/>
-          <a:ln/>
-        </p:spPr>
-        <p:txBody>
-          <a:bodyPr wrap="square" rtlCol="0" anchor="ctr"/>
-          <a:lstStyle/>
-          <a:p>
-            <a:pPr indent="0" marL="0">
-              <a:buNone/>
-            </a:pPr>
-            <a:r>
-              <a:rPr lang="en-US" sz="1200" i="1" dirty="0">
-                <a:solidFill>
-                  <a:srgbClr val="47563F"/>
-                </a:solidFill>
-                <a:latin typeface="Calibri" pitchFamily="34" charset="0"/>
-                <a:ea typeface="Calibri" pitchFamily="34" charset="-122"/>
-                <a:cs typeface="Calibri" pitchFamily="34" charset="-120"/>
-              </a:rPr>
-              <a:t>Producción actual</a:t>
-            </a:r>
-            <a:endParaRPr lang="en-US" sz="1200" dirty="0"/>
-          </a:p>
-        </p:txBody>
-      </p:sp>
-      <p:sp>
-        <p:nvSpPr>
-          <p:cNvPr id="10" name="Text 8"/>
-          <p:cNvSpPr/>
-          <p:nvPr/>
-        </p:nvSpPr>
-        <p:spPr>
-          <a:xfrm>
-            <a:off x="868680" y="2606040"/>
-            <a:ext cx="3291840" cy="1737360"/>
+            <a:off x="932688" y="1828800"/>
+            <a:ext cx="7589520" cy="594360"/>
           </a:xfrm>
           <a:prstGeom prst="rect">
             <a:avLst/>
@@ -6402,7 +6027,7 @@
               <a:buNone/>
             </a:pPr>
             <a:r>
-              <a:rPr lang="en-US" sz="1200" dirty="0">
+              <a:rPr lang="en-US" sz="1500" dirty="0">
                 <a:solidFill>
                   <a:srgbClr val="16241B"/>
                 </a:solidFill>
@@ -6410,125 +6035,42 @@
                 <a:ea typeface="Calibri" pitchFamily="34" charset="-122"/>
                 <a:cs typeface="Calibri" pitchFamily="34" charset="-120"/>
               </a:rPr>
-              <a:t>Configurado por render.yaml. HTTPS y proceso del servidor (reinicios, logs) manejados automáticamente por la plataforma. Deploy con push a la rama conectada.</a:t>
+              <a:t>El camino completo — asegurado, póliza, cobro, comisión y reportes — funciona de punta a punta.</a:t>
             </a:r>
-            <a:endParaRPr lang="en-US" sz="1200" dirty="0"/>
+            <a:endParaRPr lang="en-US" sz="1500" dirty="0"/>
           </a:p>
         </p:txBody>
       </p:sp>
       <p:sp>
         <p:nvSpPr>
-          <p:cNvPr id="11" name="Shape 9"/>
-          <p:cNvSpPr/>
-          <p:nvPr/>
-        </p:nvSpPr>
-        <p:spPr>
-          <a:xfrm>
-            <a:off x="4754880" y="1691640"/>
-            <a:ext cx="3749040" cy="2926080"/>
+          <p:cNvPr id="9" name="Shape 7"/>
+          <p:cNvSpPr/>
+          <p:nvPr/>
+        </p:nvSpPr>
+        <p:spPr>
+          <a:xfrm>
+            <a:off x="640080" y="2624328"/>
+            <a:ext cx="128016" cy="128016"/>
           </a:xfrm>
           <a:prstGeom prst="rect">
             <a:avLst/>
           </a:prstGeom>
           <a:solidFill>
-            <a:srgbClr val="DCE6D5"/>
+            <a:srgbClr val="1A56DB"/>
           </a:solidFill>
-          <a:ln w="12700">
-            <a:solidFill>
-              <a:srgbClr val="A8BBA1"/>
-            </a:solidFill>
-            <a:prstDash val="solid"/>
-          </a:ln>
-        </p:spPr>
-      </p:sp>
-      <p:sp>
-        <p:nvSpPr>
-          <p:cNvPr id="12" name="Text 10"/>
-          <p:cNvSpPr/>
-          <p:nvPr/>
-        </p:nvSpPr>
-        <p:spPr>
-          <a:xfrm>
-            <a:off x="4983480" y="1874520"/>
-            <a:ext cx="3291840" cy="320040"/>
-          </a:xfrm>
-          <a:prstGeom prst="rect">
-            <a:avLst/>
-          </a:prstGeom>
-          <a:noFill/>
           <a:ln/>
         </p:spPr>
-        <p:txBody>
-          <a:bodyPr wrap="square" rtlCol="0" anchor="ctr"/>
-          <a:lstStyle/>
-          <a:p>
-            <a:pPr indent="0" marL="0">
-              <a:buNone/>
-            </a:pPr>
-            <a:r>
-              <a:rPr lang="en-US" sz="1300" b="1" dirty="0">
-                <a:solidFill>
-                  <a:srgbClr val="93713D"/>
-                </a:solidFill>
-                <a:latin typeface="Consolas" pitchFamily="34" charset="0"/>
-                <a:ea typeface="Consolas" pitchFamily="34" charset="-122"/>
-                <a:cs typeface="Consolas" pitchFamily="34" charset="-120"/>
-              </a:rPr>
-              <a:t>DOCKER</a:t>
-            </a:r>
-            <a:endParaRPr lang="en-US" sz="1300" dirty="0"/>
-          </a:p>
-        </p:txBody>
-      </p:sp>
-      <p:sp>
-        <p:nvSpPr>
-          <p:cNvPr id="13" name="Text 11"/>
-          <p:cNvSpPr/>
-          <p:nvPr/>
-        </p:nvSpPr>
-        <p:spPr>
-          <a:xfrm>
-            <a:off x="4983480" y="2221992"/>
-            <a:ext cx="3291840" cy="274320"/>
-          </a:xfrm>
-          <a:prstGeom prst="rect">
-            <a:avLst/>
-          </a:prstGeom>
-          <a:noFill/>
-          <a:ln/>
-        </p:spPr>
-        <p:txBody>
-          <a:bodyPr wrap="square" rtlCol="0" anchor="ctr"/>
-          <a:lstStyle/>
-          <a:p>
-            <a:pPr indent="0" marL="0">
-              <a:buNone/>
-            </a:pPr>
-            <a:r>
-              <a:rPr lang="en-US" sz="1200" i="1" dirty="0">
-                <a:solidFill>
-                  <a:srgbClr val="47563F"/>
-                </a:solidFill>
-                <a:latin typeface="Calibri" pitchFamily="34" charset="0"/>
-                <a:ea typeface="Calibri" pitchFamily="34" charset="-122"/>
-                <a:cs typeface="Calibri" pitchFamily="34" charset="-120"/>
-              </a:rPr>
-              <a:t>Alternativa portable</a:t>
-            </a:r>
-            <a:endParaRPr lang="en-US" sz="1200" dirty="0"/>
-          </a:p>
-        </p:txBody>
-      </p:sp>
-      <p:sp>
-        <p:nvSpPr>
-          <p:cNvPr id="14" name="Text 12"/>
-          <p:cNvSpPr/>
-          <p:nvPr/>
-        </p:nvSpPr>
-        <p:spPr>
-          <a:xfrm>
-            <a:off x="4983480" y="2606040"/>
-            <a:ext cx="3291840" cy="1737360"/>
+      </p:sp>
+      <p:sp>
+        <p:nvSpPr>
+          <p:cNvPr id="10" name="Text 8"/>
+          <p:cNvSpPr/>
+          <p:nvPr/>
+        </p:nvSpPr>
+        <p:spPr>
+          <a:xfrm>
+            <a:off x="932688" y="2542032"/>
+            <a:ext cx="7589520" cy="594360"/>
           </a:xfrm>
           <a:prstGeom prst="rect">
             <a:avLst/>
@@ -6544,7 +6086,7 @@
               <a:buNone/>
             </a:pPr>
             <a:r>
-              <a:rPr lang="en-US" sz="1200" dirty="0">
+              <a:rPr lang="en-US" sz="1500" dirty="0">
                 <a:solidFill>
                   <a:srgbClr val="16241B"/>
                 </a:solidFill>
@@ -6552,9 +6094,127 @@
                 <a:ea typeface="Calibri" pitchFamily="34" charset="-122"/>
                 <a:cs typeface="Calibri" pitchFamily="34" charset="-120"/>
               </a:rPr>
-              <a:t>Dockerfile + docker-compose.yml en el repositorio. Levanta el mismo código en cualquier proveedor con soporte de contenedores, sin instalar dependencias en el host.</a:t>
+              <a:t>Arquitectura simple y mantenible, sin piezas de más.</a:t>
             </a:r>
-            <a:endParaRPr lang="en-US" sz="1200" dirty="0"/>
+            <a:endParaRPr lang="en-US" sz="1500" dirty="0"/>
+          </a:p>
+        </p:txBody>
+      </p:sp>
+      <p:sp>
+        <p:nvSpPr>
+          <p:cNvPr id="11" name="Shape 9"/>
+          <p:cNvSpPr/>
+          <p:nvPr/>
+        </p:nvSpPr>
+        <p:spPr>
+          <a:xfrm>
+            <a:off x="640080" y="3337560"/>
+            <a:ext cx="128016" cy="128016"/>
+          </a:xfrm>
+          <a:prstGeom prst="rect">
+            <a:avLst/>
+          </a:prstGeom>
+          <a:solidFill>
+            <a:srgbClr val="1A56DB"/>
+          </a:solidFill>
+          <a:ln/>
+        </p:spPr>
+      </p:sp>
+      <p:sp>
+        <p:nvSpPr>
+          <p:cNvPr id="12" name="Text 10"/>
+          <p:cNvSpPr/>
+          <p:nvPr/>
+        </p:nvSpPr>
+        <p:spPr>
+          <a:xfrm>
+            <a:off x="932688" y="3255264"/>
+            <a:ext cx="7589520" cy="594360"/>
+          </a:xfrm>
+          <a:prstGeom prst="rect">
+            <a:avLst/>
+          </a:prstGeom>
+          <a:noFill/>
+          <a:ln/>
+        </p:spPr>
+        <p:txBody>
+          <a:bodyPr wrap="square" rtlCol="0" anchor="t"/>
+          <a:lstStyle/>
+          <a:p>
+            <a:pPr indent="0" marL="0">
+              <a:buNone/>
+            </a:pPr>
+            <a:r>
+              <a:rPr lang="en-US" sz="1500" dirty="0">
+                <a:solidFill>
+                  <a:srgbClr val="16241B"/>
+                </a:solidFill>
+                <a:latin typeface="Calibri" pitchFamily="34" charset="0"/>
+                <a:ea typeface="Calibri" pitchFamily="34" charset="-122"/>
+                <a:cs typeface="Calibri" pitchFamily="34" charset="-120"/>
+              </a:rPr>
+              <a:t>Deuda técnica identificada y priorizada, no descubierta a último momento.</a:t>
+            </a:r>
+            <a:endParaRPr lang="en-US" sz="1500" dirty="0"/>
+          </a:p>
+        </p:txBody>
+      </p:sp>
+      <p:sp>
+        <p:nvSpPr>
+          <p:cNvPr id="13" name="Shape 11"/>
+          <p:cNvSpPr/>
+          <p:nvPr/>
+        </p:nvSpPr>
+        <p:spPr>
+          <a:xfrm>
+            <a:off x="640080" y="4050792"/>
+            <a:ext cx="128016" cy="128016"/>
+          </a:xfrm>
+          <a:prstGeom prst="rect">
+            <a:avLst/>
+          </a:prstGeom>
+          <a:solidFill>
+            <a:srgbClr val="1A56DB"/>
+          </a:solidFill>
+          <a:ln/>
+        </p:spPr>
+      </p:sp>
+      <p:sp>
+        <p:nvSpPr>
+          <p:cNvPr id="14" name="Text 12"/>
+          <p:cNvSpPr/>
+          <p:nvPr/>
+        </p:nvSpPr>
+        <p:spPr>
+          <a:xfrm>
+            <a:off x="932688" y="3968496"/>
+            <a:ext cx="7589520" cy="594360"/>
+          </a:xfrm>
+          <a:prstGeom prst="rect">
+            <a:avLst/>
+          </a:prstGeom>
+          <a:noFill/>
+          <a:ln/>
+        </p:spPr>
+        <p:txBody>
+          <a:bodyPr wrap="square" rtlCol="0" anchor="t"/>
+          <a:lstStyle/>
+          <a:p>
+            <a:pPr indent="0" marL="0">
+              <a:buNone/>
+            </a:pPr>
+            <a:r>
+              <a:rPr lang="en-US" sz="1500" dirty="0">
+                <a:solidFill>
+                  <a:srgbClr val="16241B"/>
+                </a:solidFill>
+                <a:latin typeface="Calibri" pitchFamily="34" charset="0"/>
+                <a:ea typeface="Calibri" pitchFamily="34" charset="-122"/>
+                <a:cs typeface="Calibri" pitchFamily="34" charset="-120"/>
+              </a:rPr>
+              <a:t>Sistema activo, en uso real por el equipo de la corredora.</a:t>
+            </a:r>
+            <a:endParaRPr lang="en-US" sz="1500" dirty="0"/>
           </a:p>
         </p:txBody>
       </p:sp>
@@ -6670,7 +6330,7 @@
                 <a:ea typeface="Consolas" pitchFamily="34" charset="-122"/>
                 <a:cs typeface="Consolas" pitchFamily="34" charset="-120"/>
               </a:rPr>
-              <a:t>08</a:t>
+              <a:t>07</a:t>
             </a:r>
             <a:endParaRPr lang="en-US" sz="1100" dirty="0"/>
           </a:p>
@@ -6709,439 +6369,7 @@
                 <a:ea typeface="Consolas" pitchFamily="34" charset="-122"/>
                 <a:cs typeface="Consolas" pitchFamily="34" charset="-120"/>
               </a:rPr>
-              <a:t>ESTADO ACTUAL</a:t>
-            </a:r>
-            <a:endParaRPr lang="en-US" sz="1100" dirty="0"/>
-          </a:p>
-        </p:txBody>
-      </p:sp>
-      <p:sp>
-        <p:nvSpPr>
-          <p:cNvPr id="6" name="Text 4"/>
-          <p:cNvSpPr/>
-          <p:nvPr/>
-        </p:nvSpPr>
-        <p:spPr>
-          <a:xfrm>
-            <a:off x="640080" y="868680"/>
-            <a:ext cx="7863840" cy="640080"/>
-          </a:xfrm>
-          <a:prstGeom prst="rect">
-            <a:avLst/>
-          </a:prstGeom>
-          <a:noFill/>
-          <a:ln/>
-        </p:spPr>
-        <p:txBody>
-          <a:bodyPr wrap="square" rtlCol="0" anchor="t"/>
-          <a:lstStyle/>
-          <a:p>
-            <a:pPr indent="0" marL="0">
-              <a:buNone/>
-            </a:pPr>
-            <a:r>
-              <a:rPr lang="en-US" sz="2800" b="1" dirty="0">
-                <a:solidFill>
-                  <a:srgbClr val="16241B"/>
-                </a:solidFill>
-                <a:latin typeface="Georgia" pitchFamily="34" charset="0"/>
-                <a:ea typeface="Georgia" pitchFamily="34" charset="-122"/>
-                <a:cs typeface="Georgia" pitchFamily="34" charset="-120"/>
-              </a:rPr>
-              <a:t>Dónde está el proyecto hoy</a:t>
-            </a:r>
-            <a:endParaRPr lang="en-US" sz="2800" dirty="0"/>
-          </a:p>
-        </p:txBody>
-      </p:sp>
-      <p:sp>
-        <p:nvSpPr>
-          <p:cNvPr id="7" name="Shape 5"/>
-          <p:cNvSpPr/>
-          <p:nvPr/>
-        </p:nvSpPr>
-        <p:spPr>
-          <a:xfrm>
-            <a:off x="640080" y="1801368"/>
-            <a:ext cx="128016" cy="128016"/>
-          </a:xfrm>
-          <a:prstGeom prst="rect">
-            <a:avLst/>
-          </a:prstGeom>
-          <a:solidFill>
-            <a:srgbClr val="1A56DB"/>
-          </a:solidFill>
-          <a:ln/>
-        </p:spPr>
-      </p:sp>
-      <p:sp>
-        <p:nvSpPr>
-          <p:cNvPr id="8" name="Text 6"/>
-          <p:cNvSpPr/>
-          <p:nvPr/>
-        </p:nvSpPr>
-        <p:spPr>
-          <a:xfrm>
-            <a:off x="932688" y="1737360"/>
-            <a:ext cx="7589520" cy="685800"/>
-          </a:xfrm>
-          <a:prstGeom prst="rect">
-            <a:avLst/>
-          </a:prstGeom>
-          <a:noFill/>
-          <a:ln/>
-        </p:spPr>
-        <p:txBody>
-          <a:bodyPr wrap="square" rtlCol="0" anchor="t"/>
-          <a:lstStyle/>
-          <a:p>
-            <a:pPr indent="0" marL="0">
-              <a:buNone/>
-            </a:pPr>
-            <a:r>
-              <a:rPr lang="en-US" sz="1300" dirty="0">
-                <a:solidFill>
-                  <a:srgbClr val="16241B"/>
-                </a:solidFill>
-                <a:latin typeface="Calibri" pitchFamily="34" charset="0"/>
-                <a:ea typeface="Calibri" pitchFamily="34" charset="-122"/>
-                <a:cs typeface="Calibri" pitchFamily="34" charset="-120"/>
-              </a:rPr>
-              <a:t>El camino completo — alta de asegurado, póliza, cobro, comisión y reportes — funciona de punta a punta hoy en producción.</a:t>
-            </a:r>
-            <a:endParaRPr lang="en-US" sz="1300" dirty="0"/>
-          </a:p>
-        </p:txBody>
-      </p:sp>
-      <p:sp>
-        <p:nvSpPr>
-          <p:cNvPr id="9" name="Shape 7"/>
-          <p:cNvSpPr/>
-          <p:nvPr/>
-        </p:nvSpPr>
-        <p:spPr>
-          <a:xfrm>
-            <a:off x="640080" y="2578608"/>
-            <a:ext cx="128016" cy="128016"/>
-          </a:xfrm>
-          <a:prstGeom prst="rect">
-            <a:avLst/>
-          </a:prstGeom>
-          <a:solidFill>
-            <a:srgbClr val="1A56DB"/>
-          </a:solidFill>
-          <a:ln/>
-        </p:spPr>
-      </p:sp>
-      <p:sp>
-        <p:nvSpPr>
-          <p:cNvPr id="10" name="Text 8"/>
-          <p:cNvSpPr/>
-          <p:nvPr/>
-        </p:nvSpPr>
-        <p:spPr>
-          <a:xfrm>
-            <a:off x="932688" y="2514600"/>
-            <a:ext cx="7589520" cy="685800"/>
-          </a:xfrm>
-          <a:prstGeom prst="rect">
-            <a:avLst/>
-          </a:prstGeom>
-          <a:noFill/>
-          <a:ln/>
-        </p:spPr>
-        <p:txBody>
-          <a:bodyPr wrap="square" rtlCol="0" anchor="t"/>
-          <a:lstStyle/>
-          <a:p>
-            <a:pPr indent="0" marL="0">
-              <a:buNone/>
-            </a:pPr>
-            <a:r>
-              <a:rPr lang="en-US" sz="1300" dirty="0">
-                <a:solidFill>
-                  <a:srgbClr val="16241B"/>
-                </a:solidFill>
-                <a:latin typeface="Calibri" pitchFamily="34" charset="0"/>
-                <a:ea typeface="Calibri" pitchFamily="34" charset="-122"/>
-                <a:cs typeface="Calibri" pitchFamily="34" charset="-120"/>
-              </a:rPr>
-              <a:t>La arquitectura es simple y directa a propósito: un monolito Flask sin capas de abstracción innecesarias, fácil de razonar para el equipo actual.</a:t>
-            </a:r>
-            <a:endParaRPr lang="en-US" sz="1300" dirty="0"/>
-          </a:p>
-        </p:txBody>
-      </p:sp>
-      <p:sp>
-        <p:nvSpPr>
-          <p:cNvPr id="11" name="Shape 9"/>
-          <p:cNvSpPr/>
-          <p:nvPr/>
-        </p:nvSpPr>
-        <p:spPr>
-          <a:xfrm>
-            <a:off x="640080" y="3355848"/>
-            <a:ext cx="128016" cy="128016"/>
-          </a:xfrm>
-          <a:prstGeom prst="rect">
-            <a:avLst/>
-          </a:prstGeom>
-          <a:solidFill>
-            <a:srgbClr val="1A56DB"/>
-          </a:solidFill>
-          <a:ln/>
-        </p:spPr>
-      </p:sp>
-      <p:sp>
-        <p:nvSpPr>
-          <p:cNvPr id="12" name="Text 10"/>
-          <p:cNvSpPr/>
-          <p:nvPr/>
-        </p:nvSpPr>
-        <p:spPr>
-          <a:xfrm>
-            <a:off x="932688" y="3291840"/>
-            <a:ext cx="7589520" cy="685800"/>
-          </a:xfrm>
-          <a:prstGeom prst="rect">
-            <a:avLst/>
-          </a:prstGeom>
-          <a:noFill/>
-          <a:ln/>
-        </p:spPr>
-        <p:txBody>
-          <a:bodyPr wrap="square" rtlCol="0" anchor="t"/>
-          <a:lstStyle/>
-          <a:p>
-            <a:pPr indent="0" marL="0">
-              <a:buNone/>
-            </a:pPr>
-            <a:r>
-              <a:rPr lang="en-US" sz="1300" dirty="0">
-                <a:solidFill>
-                  <a:srgbClr val="16241B"/>
-                </a:solidFill>
-                <a:latin typeface="Calibri" pitchFamily="34" charset="0"/>
-                <a:ea typeface="Calibri" pitchFamily="34" charset="-122"/>
-                <a:cs typeface="Calibri" pitchFamily="34" charset="-120"/>
-              </a:rPr>
-              <a:t>Hay deuda técnica identificada y priorizada (sin tests automatizados, sin CSRF, sin connection pooling, entre otros).</a:t>
-            </a:r>
-            <a:endParaRPr lang="en-US" sz="1300" dirty="0"/>
-          </a:p>
-        </p:txBody>
-      </p:sp>
-      <p:sp>
-        <p:nvSpPr>
-          <p:cNvPr id="13" name="Shape 11"/>
-          <p:cNvSpPr/>
-          <p:nvPr/>
-        </p:nvSpPr>
-        <p:spPr>
-          <a:xfrm>
-            <a:off x="640080" y="4133088"/>
-            <a:ext cx="128016" cy="128016"/>
-          </a:xfrm>
-          <a:prstGeom prst="rect">
-            <a:avLst/>
-          </a:prstGeom>
-          <a:solidFill>
-            <a:srgbClr val="1A56DB"/>
-          </a:solidFill>
-          <a:ln/>
-        </p:spPr>
-      </p:sp>
-      <p:sp>
-        <p:nvSpPr>
-          <p:cNvPr id="14" name="Text 12"/>
-          <p:cNvSpPr/>
-          <p:nvPr/>
-        </p:nvSpPr>
-        <p:spPr>
-          <a:xfrm>
-            <a:off x="932688" y="4069080"/>
-            <a:ext cx="7589520" cy="685800"/>
-          </a:xfrm>
-          <a:prstGeom prst="rect">
-            <a:avLst/>
-          </a:prstGeom>
-          <a:noFill/>
-          <a:ln/>
-        </p:spPr>
-        <p:txBody>
-          <a:bodyPr wrap="square" rtlCol="0" anchor="t"/>
-          <a:lstStyle/>
-          <a:p>
-            <a:pPr indent="0" marL="0">
-              <a:buNone/>
-            </a:pPr>
-            <a:r>
-              <a:rPr lang="en-US" sz="1300" dirty="0">
-                <a:solidFill>
-                  <a:srgbClr val="16241B"/>
-                </a:solidFill>
-                <a:latin typeface="Calibri" pitchFamily="34" charset="0"/>
-                <a:ea typeface="Calibri" pitchFamily="34" charset="-122"/>
-                <a:cs typeface="Calibri" pitchFamily="34" charset="-120"/>
-              </a:rPr>
-              <a:t>El sistema está activo y en uso, con una base de datos real en TiDB Cloud y despliegue reproducible tanto en Render como en Docker.</a:t>
-            </a:r>
-            <a:endParaRPr lang="en-US" sz="1300" dirty="0"/>
-          </a:p>
-        </p:txBody>
-      </p:sp>
-    </p:spTree>
-  </p:cSld>
-  <p:clrMapOvr>
-    <a:masterClrMapping/>
-  </p:clrMapOvr>
-</p:sld>
-</file>
-
-<file path=ppt/slides/slide9.xml><?xml version="1.0" encoding="utf-8"?>
-<p:sld xmlns:a="http://schemas.openxmlformats.org/drawingml/2006/main" xmlns:r="http://schemas.openxmlformats.org/officeDocument/2006/relationships" xmlns:p="http://schemas.openxmlformats.org/presentationml/2006/main">
-  <p:cSld name="Slide 9">
-    <p:bg>
-      <p:bgPr>
-        <a:solidFill>
-          <a:srgbClr val="E7EEE3"/>
-        </a:solidFill>
-      </p:bgPr>
-    </p:bg>
-    <p:spTree>
-      <p:nvGrpSpPr>
-        <p:cNvPr id="1" name=""/>
-        <p:cNvGrpSpPr/>
-        <p:nvPr/>
-      </p:nvGrpSpPr>
-      <p:grpSpPr>
-        <a:xfrm>
-          <a:off x="0" y="0"/>
-          <a:ext cx="0" cy="0"/>
-          <a:chOff x="0" y="0"/>
-          <a:chExt cx="0" cy="0"/>
-        </a:xfrm>
-      </p:grpSpPr>
-      <p:sp>
-        <p:nvSpPr>
-          <p:cNvPr id="2" name="Shape 0"/>
-          <p:cNvSpPr/>
-          <p:nvPr/>
-        </p:nvSpPr>
-        <p:spPr>
-          <a:xfrm>
-            <a:off x="109728" y="109728"/>
-            <a:ext cx="8924544" cy="4928616"/>
-          </a:xfrm>
-          <a:prstGeom prst="rect">
-            <a:avLst/>
-          </a:prstGeom>
-          <a:ln w="12700">
-            <a:solidFill>
-              <a:srgbClr val="A8BBA1"/>
-            </a:solidFill>
-            <a:prstDash val="solid"/>
-          </a:ln>
-        </p:spPr>
-      </p:sp>
-      <p:sp>
-        <p:nvSpPr>
-          <p:cNvPr id="3" name="Shape 1"/>
-          <p:cNvSpPr/>
-          <p:nvPr/>
-        </p:nvSpPr>
-        <p:spPr>
-          <a:xfrm>
-            <a:off x="109728" y="109728"/>
-            <a:ext cx="512064" cy="310896"/>
-          </a:xfrm>
-          <a:prstGeom prst="rect">
-            <a:avLst/>
-          </a:prstGeom>
-          <a:solidFill>
-            <a:srgbClr val="DCE6D5"/>
-          </a:solidFill>
-          <a:ln w="12700">
-            <a:solidFill>
-              <a:srgbClr val="A8BBA1"/>
-            </a:solidFill>
-            <a:prstDash val="solid"/>
-          </a:ln>
-        </p:spPr>
-      </p:sp>
-      <p:sp>
-        <p:nvSpPr>
-          <p:cNvPr id="4" name="Text 2"/>
-          <p:cNvSpPr/>
-          <p:nvPr/>
-        </p:nvSpPr>
-        <p:spPr>
-          <a:xfrm>
-            <a:off x="109728" y="109728"/>
-            <a:ext cx="512064" cy="310896"/>
-          </a:xfrm>
-          <a:prstGeom prst="rect">
-            <a:avLst/>
-          </a:prstGeom>
-          <a:noFill/>
-          <a:ln/>
-        </p:spPr>
-        <p:txBody>
-          <a:bodyPr wrap="square" rtlCol="0" anchor="ctr"/>
-          <a:lstStyle/>
-          <a:p>
-            <a:pPr algn="ctr" indent="0" marL="0">
-              <a:buNone/>
-            </a:pPr>
-            <a:r>
-              <a:rPr lang="en-US" sz="1100" b="1" dirty="0">
-                <a:solidFill>
-                  <a:srgbClr val="93713D"/>
-                </a:solidFill>
-                <a:latin typeface="Consolas" pitchFamily="34" charset="0"/>
-                <a:ea typeface="Consolas" pitchFamily="34" charset="-122"/>
-                <a:cs typeface="Consolas" pitchFamily="34" charset="-120"/>
-              </a:rPr>
-              <a:t>09</a:t>
-            </a:r>
-            <a:endParaRPr lang="en-US" sz="1100" dirty="0"/>
-          </a:p>
-        </p:txBody>
-      </p:sp>
-      <p:sp>
-        <p:nvSpPr>
-          <p:cNvPr id="5" name="Text 3"/>
-          <p:cNvSpPr/>
-          <p:nvPr/>
-        </p:nvSpPr>
-        <p:spPr>
-          <a:xfrm>
-            <a:off x="640080" y="502920"/>
-            <a:ext cx="7863840" cy="274320"/>
-          </a:xfrm>
-          <a:prstGeom prst="rect">
-            <a:avLst/>
-          </a:prstGeom>
-          <a:noFill/>
-          <a:ln/>
-        </p:spPr>
-        <p:txBody>
-          <a:bodyPr wrap="square" rtlCol="0" anchor="ctr"/>
-          <a:lstStyle/>
-          <a:p>
-            <a:pPr indent="0" marL="0">
-              <a:buNone/>
-            </a:pPr>
-            <a:r>
-              <a:rPr lang="en-US" sz="1100" b="1" spc="200" kern="0" dirty="0">
-                <a:solidFill>
-                  <a:srgbClr val="93713D"/>
-                </a:solidFill>
-                <a:latin typeface="Consolas" pitchFamily="34" charset="0"/>
-                <a:ea typeface="Consolas" pitchFamily="34" charset="-122"/>
-                <a:cs typeface="Consolas" pitchFamily="34" charset="-120"/>
-              </a:rPr>
-              <a:t>LIMITACIONES CONOCIDAS</a:t>
+              <a:t>LIMITACIONES CONOCIDAS Y PRÓXIMOS PASOS</a:t>
             </a:r>
             <a:endParaRPr lang="en-US" sz="1100" dirty="0"/>
           </a:p>
@@ -7188,7 +6416,7 @@
       </p:sp>
       <p:graphicFrame>
         <p:nvGraphicFramePr>
-          <p:cNvPr id="10" name="Table 0"/>
+          <p:cNvPr id="9" name="Table 0"/>
           <p:cNvGraphicFramePr>
             <a:graphicFrameLocks noGrp="1"/>
           </p:cNvGraphicFramePr>
@@ -8659,6 +7887,300 @@
           </a:graphicData>
         </a:graphic>
       </p:graphicFrame>
+    </p:spTree>
+  </p:cSld>
+  <p:clrMapOvr>
+    <a:masterClrMapping/>
+  </p:clrMapOvr>
+</p:sld>
+</file>
+
+<file path=ppt/slides/slide9.xml><?xml version="1.0" encoding="utf-8"?>
+<p:sld xmlns:a="http://schemas.openxmlformats.org/drawingml/2006/main" xmlns:r="http://schemas.openxmlformats.org/officeDocument/2006/relationships" xmlns:p="http://schemas.openxmlformats.org/presentationml/2006/main">
+  <p:cSld name="Slide 9">
+    <p:bg>
+      <p:bgPr>
+        <a:solidFill>
+          <a:srgbClr val="E7EEE3"/>
+        </a:solidFill>
+      </p:bgPr>
+    </p:bg>
+    <p:spTree>
+      <p:nvGrpSpPr>
+        <p:cNvPr id="1" name=""/>
+        <p:cNvGrpSpPr/>
+        <p:nvPr/>
+      </p:nvGrpSpPr>
+      <p:grpSpPr>
+        <a:xfrm>
+          <a:off x="0" y="0"/>
+          <a:ext cx="0" cy="0"/>
+          <a:chOff x="0" y="0"/>
+          <a:chExt cx="0" cy="0"/>
+        </a:xfrm>
+      </p:grpSpPr>
+      <p:sp>
+        <p:nvSpPr>
+          <p:cNvPr id="2" name="Shape 0"/>
+          <p:cNvSpPr/>
+          <p:nvPr/>
+        </p:nvSpPr>
+        <p:spPr>
+          <a:xfrm>
+            <a:off x="109728" y="109728"/>
+            <a:ext cx="8924544" cy="4928616"/>
+          </a:xfrm>
+          <a:prstGeom prst="rect">
+            <a:avLst/>
+          </a:prstGeom>
+          <a:ln w="12700">
+            <a:solidFill>
+              <a:srgbClr val="A8BBA1"/>
+            </a:solidFill>
+            <a:prstDash val="solid"/>
+          </a:ln>
+        </p:spPr>
+      </p:sp>
+      <p:sp>
+        <p:nvSpPr>
+          <p:cNvPr id="3" name="Shape 1"/>
+          <p:cNvSpPr/>
+          <p:nvPr/>
+        </p:nvSpPr>
+        <p:spPr>
+          <a:xfrm>
+            <a:off x="109728" y="109728"/>
+            <a:ext cx="512064" cy="310896"/>
+          </a:xfrm>
+          <a:prstGeom prst="rect">
+            <a:avLst/>
+          </a:prstGeom>
+          <a:solidFill>
+            <a:srgbClr val="DCE6D5"/>
+          </a:solidFill>
+          <a:ln w="12700">
+            <a:solidFill>
+              <a:srgbClr val="A8BBA1"/>
+            </a:solidFill>
+            <a:prstDash val="solid"/>
+          </a:ln>
+        </p:spPr>
+      </p:sp>
+      <p:sp>
+        <p:nvSpPr>
+          <p:cNvPr id="4" name="Text 2"/>
+          <p:cNvSpPr/>
+          <p:nvPr/>
+        </p:nvSpPr>
+        <p:spPr>
+          <a:xfrm>
+            <a:off x="109728" y="109728"/>
+            <a:ext cx="512064" cy="310896"/>
+          </a:xfrm>
+          <a:prstGeom prst="rect">
+            <a:avLst/>
+          </a:prstGeom>
+          <a:noFill/>
+          <a:ln/>
+        </p:spPr>
+        <p:txBody>
+          <a:bodyPr wrap="square" rtlCol="0" anchor="ctr"/>
+          <a:lstStyle/>
+          <a:p>
+            <a:pPr algn="ctr" indent="0" marL="0">
+              <a:buNone/>
+            </a:pPr>
+            <a:r>
+              <a:rPr lang="en-US" sz="1100" b="1" dirty="0">
+                <a:solidFill>
+                  <a:srgbClr val="93713D"/>
+                </a:solidFill>
+                <a:latin typeface="Consolas" pitchFamily="34" charset="0"/>
+                <a:ea typeface="Consolas" pitchFamily="34" charset="-122"/>
+                <a:cs typeface="Consolas" pitchFamily="34" charset="-120"/>
+              </a:rPr>
+              <a:t>08</a:t>
+            </a:r>
+            <a:endParaRPr lang="en-US" sz="1100" dirty="0"/>
+          </a:p>
+        </p:txBody>
+      </p:sp>
+      <p:sp>
+        <p:nvSpPr>
+          <p:cNvPr id="5" name="Text 3"/>
+          <p:cNvSpPr/>
+          <p:nvPr/>
+        </p:nvSpPr>
+        <p:spPr>
+          <a:xfrm>
+            <a:off x="640080" y="502920"/>
+            <a:ext cx="7863840" cy="274320"/>
+          </a:xfrm>
+          <a:prstGeom prst="rect">
+            <a:avLst/>
+          </a:prstGeom>
+          <a:noFill/>
+          <a:ln/>
+        </p:spPr>
+        <p:txBody>
+          <a:bodyPr wrap="square" rtlCol="0" anchor="ctr"/>
+          <a:lstStyle/>
+          <a:p>
+            <a:pPr indent="0" marL="0">
+              <a:buNone/>
+            </a:pPr>
+            <a:r>
+              <a:rPr lang="en-US" sz="1100" b="1" spc="200" kern="0" dirty="0">
+                <a:solidFill>
+                  <a:srgbClr val="93713D"/>
+                </a:solidFill>
+                <a:latin typeface="Consolas" pitchFamily="34" charset="0"/>
+                <a:ea typeface="Consolas" pitchFamily="34" charset="-122"/>
+                <a:cs typeface="Consolas" pitchFamily="34" charset="-120"/>
+              </a:rPr>
+              <a:t>CIERRE</a:t>
+            </a:r>
+            <a:endParaRPr lang="en-US" sz="1100" dirty="0"/>
+          </a:p>
+        </p:txBody>
+      </p:sp>
+      <p:sp>
+        <p:nvSpPr>
+          <p:cNvPr id="6" name="Text 4"/>
+          <p:cNvSpPr/>
+          <p:nvPr/>
+        </p:nvSpPr>
+        <p:spPr>
+          <a:xfrm>
+            <a:off x="640080" y="1691640"/>
+            <a:ext cx="7863840" cy="1005840"/>
+          </a:xfrm>
+          <a:prstGeom prst="rect">
+            <a:avLst/>
+          </a:prstGeom>
+          <a:noFill/>
+          <a:ln/>
+        </p:spPr>
+        <p:txBody>
+          <a:bodyPr wrap="square" rtlCol="0" anchor="ctr"/>
+          <a:lstStyle/>
+          <a:p>
+            <a:pPr indent="0" marL="0">
+              <a:buNone/>
+            </a:pPr>
+            <a:r>
+              <a:rPr lang="en-US" sz="4400" b="1" dirty="0">
+                <a:solidFill>
+                  <a:srgbClr val="16241B"/>
+                </a:solidFill>
+                <a:latin typeface="Georgia" pitchFamily="34" charset="0"/>
+                <a:ea typeface="Georgia" pitchFamily="34" charset="-122"/>
+                <a:cs typeface="Georgia" pitchFamily="34" charset="-120"/>
+              </a:rPr>
+              <a:t>Ahora, en vivo.</a:t>
+            </a:r>
+            <a:endParaRPr lang="en-US" sz="4400" dirty="0"/>
+          </a:p>
+        </p:txBody>
+      </p:sp>
+      <p:sp>
+        <p:nvSpPr>
+          <p:cNvPr id="7" name="Shape 5"/>
+          <p:cNvSpPr/>
+          <p:nvPr/>
+        </p:nvSpPr>
+        <p:spPr>
+          <a:xfrm>
+            <a:off x="658368" y="2697480"/>
+            <a:ext cx="2194560" cy="54864"/>
+          </a:xfrm>
+          <a:prstGeom prst="rect">
+            <a:avLst/>
+          </a:prstGeom>
+          <a:solidFill>
+            <a:srgbClr val="1A56DB"/>
+          </a:solidFill>
+          <a:ln/>
+        </p:spPr>
+      </p:sp>
+      <p:sp>
+        <p:nvSpPr>
+          <p:cNvPr id="8" name="Text 6"/>
+          <p:cNvSpPr/>
+          <p:nvPr/>
+        </p:nvSpPr>
+        <p:spPr>
+          <a:xfrm>
+            <a:off x="640080" y="2926080"/>
+            <a:ext cx="7680960" cy="822960"/>
+          </a:xfrm>
+          <a:prstGeom prst="rect">
+            <a:avLst/>
+          </a:prstGeom>
+          <a:noFill/>
+          <a:ln/>
+        </p:spPr>
+        <p:txBody>
+          <a:bodyPr wrap="square" rtlCol="0" anchor="t"/>
+          <a:lstStyle/>
+          <a:p>
+            <a:pPr indent="0" marL="0">
+              <a:buNone/>
+            </a:pPr>
+            <a:r>
+              <a:rPr lang="en-US" sz="1500" dirty="0">
+                <a:solidFill>
+                  <a:srgbClr val="47563F"/>
+                </a:solidFill>
+                <a:latin typeface="Calibri" pitchFamily="34" charset="0"/>
+                <a:ea typeface="Calibri" pitchFamily="34" charset="-122"/>
+                <a:cs typeface="Calibri" pitchFamily="34" charset="-120"/>
+              </a:rPr>
+              <a:t>Recorrido de punta a punta: registrar un asegurado, su póliza, un pago, una comisión recibida, y cierre con el dashboard y el reporte Sudaseg.</a:t>
+            </a:r>
+            <a:endParaRPr lang="en-US" sz="1500" dirty="0"/>
+          </a:p>
+        </p:txBody>
+      </p:sp>
+      <p:sp>
+        <p:nvSpPr>
+          <p:cNvPr id="9" name="Text 7"/>
+          <p:cNvSpPr/>
+          <p:nvPr/>
+        </p:nvSpPr>
+        <p:spPr>
+          <a:xfrm>
+            <a:off x="640080" y="4690872"/>
+            <a:ext cx="7863840" cy="274320"/>
+          </a:xfrm>
+          <a:prstGeom prst="rect">
+            <a:avLst/>
+          </a:prstGeom>
+          <a:noFill/>
+          <a:ln/>
+        </p:spPr>
+        <p:txBody>
+          <a:bodyPr wrap="square" rtlCol="0" anchor="ctr"/>
+          <a:lstStyle/>
+          <a:p>
+            <a:pPr indent="0" marL="0">
+              <a:buNone/>
+            </a:pPr>
+            <a:r>
+              <a:rPr lang="en-US" sz="900" dirty="0">
+                <a:solidFill>
+                  <a:srgbClr val="47563F"/>
+                </a:solidFill>
+                <a:latin typeface="Consolas" pitchFamily="34" charset="0"/>
+                <a:ea typeface="Consolas" pitchFamily="34" charset="-122"/>
+                <a:cs typeface="Consolas" pitchFamily="34" charset="-120"/>
+              </a:rPr>
+              <a:t>BrokerCore — gestión integral para corredoras de seguros</a:t>
+            </a:r>
+            <a:endParaRPr lang="en-US" sz="900" dirty="0"/>
+          </a:p>
+        </p:txBody>
+      </p:sp>
     </p:spTree>
   </p:cSld>
   <p:clrMapOvr>

</xml_diff>